<commit_message>
F6.4: add Future scope slide (petabyte storage, processing, graph analytics); team names and live demo kept
</commit_message>
<xml_diff>
--- a/report/musin-slides.pptx
+++ b/report/musin-slides.pptx
@@ -4,16 +4,17 @@
   <p:sldMasterIdLst>
     <p:sldMasterId id="2147483648" r:id="rId1"/>
   </p:sldMasterIdLst>
+  <p:notesMasterIdLst>
+    <p:notesMasterId r:id="rId7"/>
+  </p:notesMasterIdLst>
   <p:sldIdLst>
     <p:sldId id="256" r:id="rId2"/>
     <p:sldId id="257" r:id="rId3"/>
     <p:sldId id="258" r:id="rId4"/>
     <p:sldId id="259" r:id="rId5"/>
     <p:sldId id="260" r:id="rId6"/>
+    <p:sldId id="261" r:id="rId12"/>
   </p:sldIdLst>
-  <p:notesMasterIdLst>
-    <p:notesMasterId r:id="rId7"/>
-  </p:notesMasterIdLst>
   <p:sldSz cx="12192000" cy="6858000"/>
   <p:notesSz cx="6858000" cy="12192000"/>
   <p:defaultTextStyle>
@@ -111,29 +112,34 @@
   <p:extLst>
     <p:ext uri="{521415D9-36F7-43E2-AB2F-B90AF26B5E84}">
       <p14:sectionLst xmlns:p14="http://schemas.microsoft.com/office/powerpoint/2010/main">
-        <p14:section name="Introduction" id="{81ab835d-0048-b223-e959-e28f71a3c50e}">
+        <p14:section name="Introduction" id="{81AB835D-0048-B223-E959-E28F71A3C50E}">
           <p14:sldIdLst>
             <p14:sldId id="256"/>
           </p14:sldIdLst>
         </p14:section>
-        <p14:section name="Literature review" id="{d63747c4-e92b-f0da-2150-67febb470589}">
+        <p14:section name="Literature review" id="{D63747C4-E92B-F0DA-2150-67FEBB470589}">
           <p14:sldIdLst>
             <p14:sldId id="257"/>
           </p14:sldIdLst>
         </p14:section>
-        <p14:section name="Methodology" id="{74feeeff-ab6b-85b5-45b0-aa1b667aafff}">
+        <p14:section name="Methodology" id="{74FEEEFF-AB6B-85B5-45B0-AA1B667AAFFF}">
           <p14:sldIdLst>
             <p14:sldId id="258"/>
           </p14:sldIdLst>
         </p14:section>
-        <p14:section name="Working model" id="{9f00fa0f-346b-fd8d-bb30-7bc8e665c76d}">
+        <p14:section name="Working model" id="{9F00FA0F-346B-FD8D-BB30-7BC8E665C76D}">
           <p14:sldIdLst>
             <p14:sldId id="259"/>
           </p14:sldIdLst>
         </p14:section>
-        <p14:section name="Conclusion" id="{395c6406-702e-0ee8-0875-e31314e00639}">
+        <p14:section name="Conclusion" id="{395C6406-702E-0EE8-0875-E31314E00639}">
           <p14:sldIdLst>
             <p14:sldId id="260"/>
+          </p14:sldIdLst>
+        </p14:section>
+        <p14:section name="Future scope" id="{7A1C2E55-3B9D-4F2A-9E61-5D0B8C4F6A21}">
+          <p14:sldIdLst>
+            <p14:sldId id="261"/>
           </p14:sldIdLst>
         </p14:section>
       </p14:sectionLst>
@@ -167,234 +173,10 @@
           <a:chExt cx="0" cy="0"/>
         </a:xfrm>
       </p:grpSpPr>
-      <p:sp>
-        <p:nvSpPr>
-          <p:cNvPr id="2" name="Header Placeholder 1"/>
-          <p:cNvSpPr>
-            <a:spLocks noGrp="1"/>
-          </p:cNvSpPr>
-          <p:nvPr>
-            <p:ph type="hdr" sz="quarter"/>
-          </p:nvPr>
-        </p:nvSpPr>
-        <p:spPr>
-          <a:xfrm>
-            <a:off x="0" y="0"/>
-            <a:ext cx="2971800" cy="458788"/>
-          </a:xfrm>
-          <a:prstGeom prst="rect">
-            <a:avLst/>
-          </a:prstGeom>
-        </p:spPr>
-        <p:txBody>
-          <a:bodyPr vert="horz" lIns="91440" tIns="45720" rIns="91440" bIns="45720" rtlCol="0"/>
-          <a:lstStyle>
-            <a:lvl1pPr algn="l">
-              <a:defRPr sz="1200"/>
-            </a:lvl1pPr>
-          </a:lstStyle>
-          <a:p>
-            <a:endParaRPr lang="en-US"/>
-          </a:p>
-        </p:txBody>
-      </p:sp>
-      <p:sp>
-        <p:nvSpPr>
-          <p:cNvPr id="3" name="Date Placeholder 2"/>
-          <p:cNvSpPr>
-            <a:spLocks noGrp="1"/>
-          </p:cNvSpPr>
-          <p:nvPr>
-            <p:ph type="dt" idx="1"/>
-          </p:nvPr>
-        </p:nvSpPr>
-        <p:spPr>
-          <a:xfrm>
-            <a:off x="3884613" y="0"/>
-            <a:ext cx="2971800" cy="458788"/>
-          </a:xfrm>
-          <a:prstGeom prst="rect">
-            <a:avLst/>
-          </a:prstGeom>
-        </p:spPr>
-        <p:txBody>
-          <a:bodyPr vert="horz" lIns="91440" tIns="45720" rIns="91440" bIns="45720" rtlCol="0"/>
-          <a:lstStyle>
-            <a:lvl1pPr algn="r">
-              <a:defRPr sz="1200"/>
-            </a:lvl1pPr>
-          </a:lstStyle>
-          <a:p>
-            <a:fld id="{5282F153-3F37-0F45-9E97-73ACFA13230C}" type="datetimeFigureOut">
-              <a:rPr lang="en-US"/>
-              <a:t>7/23/19</a:t>
-            </a:fld>
-            <a:endParaRPr lang="en-US"/>
-          </a:p>
-        </p:txBody>
-      </p:sp>
-      <p:sp>
-        <p:nvSpPr>
-          <p:cNvPr id="4" name="Slide Image Placeholder 3"/>
-          <p:cNvSpPr>
-            <a:spLocks noGrp="1" noRot="1" noChangeAspect="1"/>
-          </p:cNvSpPr>
-          <p:nvPr>
-            <p:ph type="sldImg" idx="2"/>
-          </p:nvPr>
-        </p:nvSpPr>
-        <p:spPr>
-          <a:xfrm>
-            <a:off x="685800" y="1143000"/>
-            <a:ext cx="5486400" cy="3086100"/>
-          </a:xfrm>
-          <a:prstGeom prst="rect">
-            <a:avLst/>
-          </a:prstGeom>
-          <a:noFill/>
-          <a:ln w="12700">
-            <a:solidFill>
-              <a:prstClr val="black"/>
-            </a:solidFill>
-          </a:ln>
-        </p:spPr>
-        <p:txBody>
-          <a:bodyPr vert="horz" lIns="91440" tIns="45720" rIns="91440" bIns="45720" rtlCol="0" anchor="ctr"/>
-          <a:lstStyle/>
-          <a:p>
-            <a:endParaRPr lang="en-US"/>
-          </a:p>
-        </p:txBody>
-      </p:sp>
-      <p:sp>
-        <p:nvSpPr>
-          <p:cNvPr id="5" name="Notes Placeholder 4"/>
-          <p:cNvSpPr>
-            <a:spLocks noGrp="1"/>
-          </p:cNvSpPr>
-          <p:nvPr>
-            <p:ph type="body" sz="quarter" idx="3"/>
-          </p:nvPr>
-        </p:nvSpPr>
-        <p:spPr>
-          <a:xfrm>
-            <a:off x="685800" y="4400550"/>
-            <a:ext cx="5486400" cy="3600450"/>
-          </a:xfrm>
-          <a:prstGeom prst="rect">
-            <a:avLst/>
-          </a:prstGeom>
-        </p:spPr>
-        <p:txBody>
-          <a:bodyPr vert="horz" lIns="91440" tIns="45720" rIns="91440" bIns="45720" rtlCol="0"/>
-          <a:lstStyle/>
-          <a:p>
-            <a:pPr lvl="0"/>
-            <a:r>
-              <a:rPr lang="en-US"/>
-              <a:t>Click to edit Master text styles</a:t>
-            </a:r>
-          </a:p>
-          <a:p>
-            <a:pPr lvl="1"/>
-            <a:r>
-              <a:rPr lang="en-US"/>
-              <a:t>Second level</a:t>
-            </a:r>
-          </a:p>
-          <a:p>
-            <a:pPr lvl="2"/>
-            <a:r>
-              <a:rPr lang="en-US"/>
-              <a:t>Third level</a:t>
-            </a:r>
-          </a:p>
-          <a:p>
-            <a:pPr lvl="3"/>
-            <a:r>
-              <a:rPr lang="en-US"/>
-              <a:t>Fourth level</a:t>
-            </a:r>
-          </a:p>
-          <a:p>
-            <a:pPr lvl="4"/>
-            <a:r>
-              <a:rPr lang="en-US"/>
-              <a:t>Fifth level</a:t>
-            </a:r>
-          </a:p>
-        </p:txBody>
-      </p:sp>
-      <p:sp>
-        <p:nvSpPr>
-          <p:cNvPr id="6" name="Footer Placeholder 5"/>
-          <p:cNvSpPr>
-            <a:spLocks noGrp="1"/>
-          </p:cNvSpPr>
-          <p:nvPr>
-            <p:ph type="ftr" sz="quarter" idx="4"/>
-          </p:nvPr>
-        </p:nvSpPr>
-        <p:spPr>
-          <a:xfrm>
-            <a:off x="0" y="8685213"/>
-            <a:ext cx="2971800" cy="458787"/>
-          </a:xfrm>
-          <a:prstGeom prst="rect">
-            <a:avLst/>
-          </a:prstGeom>
-        </p:spPr>
-        <p:txBody>
-          <a:bodyPr vert="horz" lIns="91440" tIns="45720" rIns="91440" bIns="45720" rtlCol="0" anchor="b"/>
-          <a:lstStyle>
-            <a:lvl1pPr algn="l">
-              <a:defRPr sz="1200"/>
-            </a:lvl1pPr>
-          </a:lstStyle>
-          <a:p>
-            <a:endParaRPr lang="en-US"/>
-          </a:p>
-        </p:txBody>
-      </p:sp>
-      <p:sp>
-        <p:nvSpPr>
-          <p:cNvPr id="7" name="Slide Number Placeholder 6"/>
-          <p:cNvSpPr>
-            <a:spLocks noGrp="1"/>
-          </p:cNvSpPr>
-          <p:nvPr>
-            <p:ph type="sldNum" sz="quarter" idx="5"/>
-          </p:nvPr>
-        </p:nvSpPr>
-        <p:spPr>
-          <a:xfrm>
-            <a:off x="3884613" y="8685213"/>
-            <a:ext cx="2971800" cy="458787"/>
-          </a:xfrm>
-          <a:prstGeom prst="rect">
-            <a:avLst/>
-          </a:prstGeom>
-        </p:spPr>
-        <p:txBody>
-          <a:bodyPr vert="horz" lIns="91440" tIns="45720" rIns="91440" bIns="45720" rtlCol="0" anchor="b"/>
-          <a:lstStyle>
-            <a:lvl1pPr algn="r">
-              <a:defRPr sz="1200"/>
-            </a:lvl1pPr>
-          </a:lstStyle>
-          <a:p>
-            <a:fld id="{CE5E9CC1-C706-0F49-92D6-E571CC5EEA8F}" type="slidenum">
-              <a:rPr lang="en-US"/>
-              <a:t>‹#›</a:t>
-            </a:fld>
-            <a:endParaRPr lang="en-US"/>
-          </a:p>
-        </p:txBody>
-      </p:sp>
     </p:spTree>
     <p:extLst>
       <p:ext uri="{BB962C8B-B14F-4D97-AF65-F5344CB8AC3E}">
-        <p14:creationId xmlns:p14="http://schemas.microsoft.com/office/powerpoint/2010/main" val="1024086991"/>
+        <p14:creationId xmlns:p14="http://schemas.microsoft.com/office/powerpoint/2010/main" val="607075075"/>
       </p:ext>
     </p:extLst>
   </p:cSld>
@@ -542,7 +324,6 @@
               <a:rPr lang="en-US" dirty="0"/>
               <a:t>About 45 seconds. Genres are usually studied one artist at a time, but music is made together: rappers feature singers, producers work across scenes, session players appear on country and jazz records. A collaboration graph shows who connects scenes that would otherwise be separate. MusicBrainz is the largest open music database and records exactly that: who is billed, who is featured, who produced or played. But it is relational, large and noisy, so turning it into a graph we can trust was half the work. We asked four questions: which artists bridge genres, whether collaboration communities match genres, whether cross-genre collaboration has grown over the decades, and who is most central and whether the measures agree. And we processed the complete export, not a sample.</a:t>
             </a:r>
-            <a:endParaRPr lang="en-US" dirty="0"/>
           </a:p>
         </p:txBody>
       </p:sp>
@@ -630,7 +411,6 @@
               <a:rPr lang="en-US" dirty="0"/>
               <a:t>About 45 seconds. Collaboration networks are a classic object of network science, starting with scientific co-authorship (Newman 2001). For music, Gleiser and Danon studied jazz musicians who played in the same bands and found communities that follow recording location and racial segregation. Park and colleagues built a network of contemporary popular musicians from an online music guide. Bryan and Wang ranked influence in a sampling network from WhoSampled and found funk, soul and disco behind hip hop, R&amp;B and electronic music. These studies work with curated or crawled data at the scale of thousands of artists. Our step: the complete open MusicBrainz export, about a million artists, with typed credits including producers and performers, and a bridge score that measures genre bridging directly. Our methods build on Louvain, PageRank, betweenness and NMI/AMI. Full references are in the report.</a:t>
             </a:r>
-            <a:endParaRPr lang="en-US" dirty="0"/>
           </a:p>
         </p:txBody>
       </p:sp>
@@ -718,7 +498,6 @@
               <a:rPr lang="en-US" dirty="0"/>
               <a:t>About 60 seconds. The pipeline has four stages. We download the full MusicBrainz export: 40.5 million recordings and 3 million artists. PySpark turns the headerless database dump into typed Parquet, cleans it, and builds the graph in layers: raw, clean, graph. Neo4j with the Graph Data Science library holds the final graph of 1.14 million artists and 3.08 million edges and runs the algorithms; every figure and table in the report is generated by code. The graph has four edge types, from billing credits and from producer and performer credits; the weight is the number of shared recordings. We filter placeholder artists like Various Artists, credits with more than ten artists, groups linked to their own members, and Character and classical artists, which we analyse separately as sensitivity graphs. For each question we defined a metric in advance: for bridges, genre diversity times betweenness percentile; for communities, Louvain compared with genre by NMI and AMI; for trends, the cross-genre and featuring shares per decade; for centrality, three measures and their agreement. We validated against 15 artists we listed before looking at any result, and benchmarked Spark scaling and PageRank in three engines.</a:t>
             </a:r>
-            <a:endParaRPr lang="en-US" dirty="0"/>
           </a:p>
         </p:txBody>
       </p:sp>
@@ -806,7 +585,6 @@
               <a:rPr lang="en-US" dirty="0"/>
               <a:t>About 75 seconds: play the video. The demo runs eight saved queries in the Neo4j Browser on the full graph. First the overview: 1.1 million artists and four kinds of collaboration. Then the top genre bridges; the first one, Putumayo, is a record label credited as an artist, a data artefact we discuss in the report. Then Ry Cooder, rock by tag, whose partners come from 11 genres: blues, jazz, country, latin and more; and his ego network, coloured by genre. Then degrees of separation: Frank Sinatra to Snoop Dogg in two hops, via Stevie Wonder. Then the three centrality measures, whose top tens barely overlap. Finally the largest community: hip hop with electronic producers, a scene rather than a genre. To insert the recording: Insert › Video › This Device, then resize it over the dashed frame and delete the frame; record it following docs/features/F6.2-demo.md, section 6.</a:t>
             </a:r>
-            <a:endParaRPr lang="en-US" dirty="0"/>
           </a:p>
         </p:txBody>
       </p:sp>
@@ -891,10 +669,8 @@
           <a:lstStyle/>
           <a:p>
             <a:r>
-              <a:rPr lang="en-US" dirty="0"/>
-              <a:t>About 45 seconds. Our answers. Bridges: three quarters of labelled collaboration stays within one genre, and the artists who bridge genres are mostly producers, session players and world musicians. Communities: they are strong and stable, but they are scenes defined by place and era as much as by genre; agreement with genre is low, AMI 0.186. Trends: the cross-genre share rose from 16 to 28 percent between the 1960s and the 2020s, and featuring credits took off in the 1990s. Centrality: the measures agree overall but almost not at the top. On architecture: Spark builds the full graph from the parsed credits in about six and a half minutes on eight cores, and a graph engine runs PageRank 123 times faster than Spark's graph library with the same result. Limits: only 22 percent of artists have a genre, audiobooks are still in the graph, and everything ran on one laptop. Thank you.</a:t>
-            </a:r>
-            <a:endParaRPr lang="en-US" dirty="0"/>
+              <a:t>About 45 seconds. Our answers. Bridges: three quarters of labelled collaboration stays within one genre, and the artists who bridge genres are mostly producers, session players and world musicians. Communities: they are strong and stable, but they are scenes defined by place and era as much as by genre; agreement with genre is low, AMI 0.186. Trends: the cross-genre share rose from 16 to 28 percent between the 1960s and the 2020s, and featuring credits took off in the 1990s. Centrality: the measures agree overall but almost not at the top. On architecture: Spark builds the full graph from the parsed credits in about six and a half minutes on eight cores, and a graph engine runs PageRank 123 times faster than Spark's graph library with the same result. Limits: only 22 percent of artists have a genre, audiobooks are still in the graph, and everything ran on one laptop.</a:t>
+            </a:r>
           </a:p>
         </p:txBody>
       </p:sp>
@@ -927,6 +703,87 @@
         <p14:creationId xmlns:p14="http://schemas.microsoft.com/office/powerpoint/2010/main" val="1024086991"/>
       </p:ext>
     </p:extLst>
+  </p:cSld>
+  <p:clrMapOvr>
+    <a:masterClrMapping/>
+  </p:clrMapOvr>
+</p:notes>
+</file>
+
+<file path=ppt/notesSlides/notesSlide6.xml><?xml version="1.0" encoding="utf-8"?>
+<p:notes xmlns:a="http://schemas.openxmlformats.org/drawingml/2006/main" xmlns:p="http://schemas.openxmlformats.org/presentationml/2006/main" xmlns:r="http://schemas.openxmlformats.org/officeDocument/2006/relationships">
+  <p:cSld>
+    <p:spTree>
+      <p:nvGrpSpPr>
+        <p:cNvPr id="1" name=""/>
+        <p:cNvGrpSpPr/>
+        <p:nvPr/>
+      </p:nvGrpSpPr>
+      <p:grpSpPr>
+        <a:xfrm>
+          <a:off x="0" y="0"/>
+          <a:ext cx="0" cy="0"/>
+          <a:chOff x="0" y="0"/>
+          <a:chExt cx="0" cy="0"/>
+        </a:xfrm>
+      </p:grpSpPr>
+      <p:sp>
+        <p:nvSpPr>
+          <p:cNvPr id="2" name="Slide Image Placeholder 1"/>
+          <p:cNvSpPr>
+            <a:spLocks noGrp="1" noRot="1" noChangeAspect="1"/>
+          </p:cNvSpPr>
+          <p:nvPr>
+            <p:ph type="sldImg"/>
+          </p:nvPr>
+        </p:nvSpPr>
+        <p:spPr/>
+      </p:sp>
+      <p:sp>
+        <p:nvSpPr>
+          <p:cNvPr id="3" name="Notes Placeholder 2"/>
+          <p:cNvSpPr>
+            <a:spLocks noGrp="1"/>
+          </p:cNvSpPr>
+          <p:nvPr>
+            <p:ph type="body" idx="1"/>
+          </p:nvPr>
+        </p:nvSpPr>
+        <p:spPr/>
+        <p:txBody>
+          <a:bodyPr/>
+          <a:lstStyle/>
+          <a:p>
+            <a:r>
+              <a:t>About 30 seconds. If the data grew to petabytes, three things change. Storage: instead of one laptop disk, distributed object storage like S3 or HDFS, with Parquet in a table format such as Iceberg or Delta Lake, partitioned so jobs read only what they need. Processing: the same Spark code on an autoscaling cluster, and incremental loads from MusicBrainz's replication packets instead of re-reading full dumps. Graph analytics: one Neo4j server can't hold a petabyte graph, so the algorithms run distributed, in GraphFrames or on multiple GPUs with cuGraph, using sampled or approximate measures, while Neo4j serves smaller subgraphs. The key idea: scale out, not up. Thank you.</a:t>
+            </a:r>
+          </a:p>
+        </p:txBody>
+      </p:sp>
+      <p:sp>
+        <p:nvSpPr>
+          <p:cNvPr id="4" name="Slide Number Placeholder 3"/>
+          <p:cNvSpPr>
+            <a:spLocks noGrp="1"/>
+          </p:cNvSpPr>
+          <p:nvPr>
+            <p:ph type="sldNum" sz="quarter" idx="10"/>
+          </p:nvPr>
+        </p:nvSpPr>
+        <p:spPr/>
+        <p:txBody>
+          <a:bodyPr/>
+          <a:lstStyle/>
+          <a:p>
+            <a:fld id="{F7021451-1387-4CA6-816F-3879F97B5CBC}" type="slidenum">
+              <a:rPr lang="en-US"/>
+              <a:t>2</a:t>
+            </a:fld>
+            <a:endParaRPr lang="en-US"/>
+          </a:p>
+        </p:txBody>
+      </p:sp>
+    </p:spTree>
   </p:cSld>
   <p:clrMapOvr>
     <a:masterClrMapping/>
@@ -972,6 +829,7 @@
         <a:solidFill>
           <a:schemeClr val="tx1"/>
         </a:solidFill>
+        <a:effectLst/>
       </p:bgPr>
     </p:bg>
     <p:spTree>
@@ -991,9 +849,11 @@
       <p:sp>
         <p:nvSpPr>
           <p:cNvPr id="2" name="Text 0"/>
-          <p:cNvSpPr/>
+          <p:cNvSpPr>
+            <a:spLocks noGrp="1"/>
+          </p:cNvSpPr>
           <p:nvPr>
-            <p:ph idx="100" type="title" hasCustomPrompt="1"/>
+            <p:ph type="title" idx="100" hasCustomPrompt="1"/>
           </p:nvPr>
         </p:nvSpPr>
         <p:spPr>
@@ -1010,7 +870,7 @@
         <p:txBody>
           <a:bodyPr wrap="square" rtlCol="0"/>
           <a:lstStyle>
-            <a:lvl1pPr algn="l" indent="0" marL="0">
+            <a:lvl1pPr marL="0" indent="0" algn="l">
               <a:buNone/>
               <a:defRPr lang="en-US" sz="5400" b="1" dirty="0">
                 <a:solidFill>
@@ -1020,7 +880,7 @@
             </a:lvl1pPr>
           </a:lstStyle>
           <a:p>
-            <a:pPr algn="l" indent="0" marL="0">
+            <a:pPr marL="0" indent="0" algn="l">
               <a:buNone/>
             </a:pPr>
             <a:endParaRPr lang="en-US" sz="5400" dirty="0"/>
@@ -1030,9 +890,11 @@
       <p:sp>
         <p:nvSpPr>
           <p:cNvPr id="3" name="Text 0"/>
-          <p:cNvSpPr/>
+          <p:cNvSpPr>
+            <a:spLocks noGrp="1"/>
+          </p:cNvSpPr>
           <p:nvPr>
-            <p:ph idx="101" type="body" hasCustomPrompt="1"/>
+            <p:ph type="body" idx="101" hasCustomPrompt="1"/>
           </p:nvPr>
         </p:nvSpPr>
         <p:spPr>
@@ -1049,7 +911,7 @@
         <p:txBody>
           <a:bodyPr wrap="square" rtlCol="0"/>
           <a:lstStyle>
-            <a:lvl1pPr algn="l" indent="0" marL="0">
+            <a:lvl1pPr marL="0" indent="0" algn="l">
               <a:buNone/>
               <a:defRPr lang="en-US" sz="2200" dirty="0">
                 <a:solidFill>
@@ -1059,7 +921,7 @@
             </a:lvl1pPr>
           </a:lstStyle>
           <a:p>
-            <a:pPr algn="l" indent="0" marL="0">
+            <a:pPr marL="0" indent="0" algn="l">
               <a:buNone/>
             </a:pPr>
             <a:endParaRPr lang="en-US" sz="2200" dirty="0"/>
@@ -1082,6 +944,7 @@
         <a:solidFill>
           <a:schemeClr val="bg1"/>
         </a:solidFill>
+        <a:effectLst/>
       </p:bgPr>
     </p:bg>
     <p:spTree>
@@ -1101,9 +964,11 @@
       <p:sp>
         <p:nvSpPr>
           <p:cNvPr id="2" name="Text 0"/>
-          <p:cNvSpPr/>
+          <p:cNvSpPr>
+            <a:spLocks noGrp="1"/>
+          </p:cNvSpPr>
           <p:nvPr>
-            <p:ph idx="100" type="title" hasCustomPrompt="1"/>
+            <p:ph type="title" idx="100" hasCustomPrompt="1"/>
           </p:nvPr>
         </p:nvSpPr>
         <p:spPr>
@@ -1120,7 +985,7 @@
         <p:txBody>
           <a:bodyPr wrap="square" rtlCol="0"/>
           <a:lstStyle>
-            <a:lvl1pPr algn="l" indent="0" marL="0">
+            <a:lvl1pPr marL="0" indent="0" algn="l">
               <a:buNone/>
               <a:defRPr lang="en-US" sz="3600" b="1" dirty="0">
                 <a:solidFill>
@@ -1130,7 +995,7 @@
             </a:lvl1pPr>
           </a:lstStyle>
           <a:p>
-            <a:pPr algn="l" indent="0" marL="0">
+            <a:pPr marL="0" indent="0" algn="l">
               <a:buNone/>
             </a:pPr>
             <a:endParaRPr lang="en-US" sz="3600" dirty="0"/>
@@ -1157,7 +1022,7 @@
           </a:prstGeom>
           <a:extLst>
             <a:ext uri="{C572A759-6A51-4108-AA02-DFA0A04FC94B}">
-              <ma14:wrappingTextBoxFlag xmlns:ma14="http://schemas.microsoft.com/office/mac/drawingml/2011/main" val="0"/>
+              <ma14:wrappingTextBoxFlag xmlns:ma14="http://schemas.microsoft.com/office/mac/drawingml/2011/main" xmlns="" val="0"/>
             </a:ext>
           </a:extLst>
         </p:spPr>
@@ -1175,8 +1040,8 @@
           <a:p>
             <a:pPr algn="r"/>
             <a:fld id="{F7021451-1387-4CA6-816F-3879F97B5CBC}" type="slidenum">
-              <a:rPr b="0" lang="en-US"/>
-              <a:t>1003</a:t>
+              <a:rPr lang="en-US" b="0"/>
+              <a:t>‹#›</a:t>
             </a:fld>
             <a:endParaRPr lang="en-US"/>
           </a:p>
@@ -1198,6 +1063,7 @@
         <a:solidFill>
           <a:schemeClr val="tx1"/>
         </a:solidFill>
+        <a:effectLst/>
       </p:bgPr>
     </p:bg>
     <p:spTree>
@@ -1217,9 +1083,11 @@
       <p:sp>
         <p:nvSpPr>
           <p:cNvPr id="2" name="Text 0"/>
-          <p:cNvSpPr/>
+          <p:cNvSpPr>
+            <a:spLocks noGrp="1"/>
+          </p:cNvSpPr>
           <p:nvPr>
-            <p:ph idx="100" type="title" hasCustomPrompt="1"/>
+            <p:ph type="title" idx="100" hasCustomPrompt="1"/>
           </p:nvPr>
         </p:nvSpPr>
         <p:spPr>
@@ -1236,7 +1104,7 @@
         <p:txBody>
           <a:bodyPr wrap="square" rtlCol="0"/>
           <a:lstStyle>
-            <a:lvl1pPr algn="l" indent="0" marL="0">
+            <a:lvl1pPr marL="0" indent="0" algn="l">
               <a:buNone/>
               <a:defRPr lang="en-US" sz="3600" b="1" dirty="0">
                 <a:solidFill>
@@ -1246,7 +1114,7 @@
             </a:lvl1pPr>
           </a:lstStyle>
           <a:p>
-            <a:pPr algn="l" indent="0" marL="0">
+            <a:pPr marL="0" indent="0" algn="l">
               <a:buNone/>
             </a:pPr>
             <a:endParaRPr lang="en-US" sz="3600" dirty="0"/>
@@ -1273,7 +1141,7 @@
           </a:prstGeom>
           <a:extLst>
             <a:ext uri="{C572A759-6A51-4108-AA02-DFA0A04FC94B}">
-              <ma14:wrappingTextBoxFlag xmlns:ma14="http://schemas.microsoft.com/office/mac/drawingml/2011/main" val="0"/>
+              <ma14:wrappingTextBoxFlag xmlns:ma14="http://schemas.microsoft.com/office/mac/drawingml/2011/main" xmlns="" val="0"/>
             </a:ext>
           </a:extLst>
         </p:spPr>
@@ -1291,8 +1159,8 @@
           <a:p>
             <a:pPr algn="r"/>
             <a:fld id="{F7021451-1387-4CA6-816F-3879F97B5CBC}" type="slidenum">
-              <a:rPr b="0" lang="en-US"/>
-              <a:t>1004</a:t>
+              <a:rPr lang="en-US" b="0"/>
+              <a:t>‹#›</a:t>
             </a:fld>
             <a:endParaRPr lang="en-US"/>
           </a:p>
@@ -1309,6 +1177,11 @@
 <file path=ppt/slideMasters/slideMaster1.xml><?xml version="1.0" encoding="utf-8"?>
 <p:sldMaster xmlns:a="http://schemas.openxmlformats.org/drawingml/2006/main" xmlns:r="http://schemas.openxmlformats.org/officeDocument/2006/relationships" xmlns:p="http://schemas.openxmlformats.org/presentationml/2006/main">
   <p:cSld>
+    <p:bg>
+      <p:bgRef idx="1001">
+        <a:schemeClr val="bg1"/>
+      </p:bgRef>
+    </p:bg>
     <p:spTree>
       <p:nvGrpSpPr>
         <p:cNvPr id="1" name=""/>
@@ -1343,7 +1216,7 @@
           </a:prstGeom>
           <a:extLst>
             <a:ext uri="{C572A759-6A51-4108-AA02-DFA0A04FC94B}">
-              <ma14:wrappingTextBoxFlag xmlns:ma14="http://schemas.microsoft.com/office/mac/drawingml/2011/main" val="0"/>
+              <ma14:wrappingTextBoxFlag xmlns:ma14="http://schemas.microsoft.com/office/mac/drawingml/2011/main" xmlns="" val="0"/>
             </a:ext>
           </a:extLst>
         </p:spPr>
@@ -1361,8 +1234,8 @@
           <a:p>
             <a:pPr algn="r"/>
             <a:fld id="{F7021451-1387-4CA6-816F-3879F97B5CBC}" type="slidenum">
-              <a:rPr b="0" lang="en-US"/>
-              <a:t>null</a:t>
+              <a:rPr lang="en-US" b="0"/>
+              <a:t>‹#›</a:t>
             </a:fld>
             <a:endParaRPr lang="en-US"/>
           </a:p>
@@ -1669,11 +1542,11 @@
           <a:bodyPr wrap="square" lIns="0" tIns="0" rIns="0" bIns="0" rtlCol="0" anchor="ctr"/>
           <a:lstStyle/>
           <a:p>
-            <a:pPr indent="0" marL="0">
-              <a:buNone/>
-            </a:pPr>
-            <a:r>
-              <a:rPr lang="en-US" sz="1400" b="1" spc="200" kern="0" dirty="0">
+            <a:pPr marL="0" indent="0">
+              <a:buNone/>
+            </a:pPr>
+            <a:r>
+              <a:rPr lang="en-US" sz="1400" b="1" kern="0" spc="200" dirty="0">
                 <a:solidFill>
                   <a:schemeClr val="accent4"/>
                 </a:solidFill>
@@ -1687,9 +1560,11 @@
       <p:sp>
         <p:nvSpPr>
           <p:cNvPr id="3" name="Text 0"/>
-          <p:cNvSpPr/>
+          <p:cNvSpPr>
+            <a:spLocks noGrp="1"/>
+          </p:cNvSpPr>
           <p:nvPr>
-            <p:ph idx="100" type="title" hasCustomPrompt="1"/>
+            <p:ph type="title" idx="100" hasCustomPrompt="1"/>
           </p:nvPr>
         </p:nvSpPr>
         <p:spPr>
@@ -1707,7 +1582,7 @@
           <a:bodyPr wrap="square" lIns="0" tIns="0" rIns="0" bIns="0" rtlCol="0" anchor="b"/>
           <a:lstStyle/>
           <a:p>
-            <a:pPr algn="l" indent="0" marL="0">
+            <a:pPr marL="0" indent="0" algn="l">
               <a:buNone/>
             </a:pPr>
             <a:r>
@@ -1725,9 +1600,11 @@
       <p:sp>
         <p:nvSpPr>
           <p:cNvPr id="4" name="Text 0"/>
-          <p:cNvSpPr/>
+          <p:cNvSpPr>
+            <a:spLocks noGrp="1"/>
+          </p:cNvSpPr>
           <p:nvPr>
-            <p:ph idx="101" type="body" hasCustomPrompt="1"/>
+            <p:ph type="body" idx="101" hasCustomPrompt="1"/>
           </p:nvPr>
         </p:nvSpPr>
         <p:spPr>
@@ -1745,7 +1622,7 @@
           <a:bodyPr wrap="square" lIns="0" tIns="0" rIns="0" bIns="0" rtlCol="0" anchor="t"/>
           <a:lstStyle/>
           <a:p>
-            <a:pPr algn="l" indent="0" marL="0">
+            <a:pPr marL="0" indent="0" algn="l">
               <a:buNone/>
             </a:pPr>
             <a:r>
@@ -1759,19 +1636,23 @@
             <a:endParaRPr lang="en-US" sz="2200" dirty="0"/>
           </a:p>
           <a:p>
-            <a:pPr algn="l" indent="0" marL="0">
+            <a:pPr marL="0" indent="0" algn="l">
               <a:spcBef>
                 <a:spcPts val="1400"/>
               </a:spcBef>
               <a:buNone/>
             </a:pPr>
             <a:r>
+              <a:rPr lang="en-US" sz="1600" dirty="0"/>
+              <a:t>Devansh Soni</a:t>
+            </a:r>
+            <a:r>
               <a:rPr lang="en-US" sz="1600" dirty="0">
                 <a:solidFill>
                   <a:schemeClr val="bg2"/>
                 </a:solidFill>
               </a:rPr>
-              <a:t>[Member A] · [Member B]</a:t>
+              <a:t> · Aditya Singh Kushwaha</a:t>
             </a:r>
             <a:endParaRPr lang="en-US" sz="2200" dirty="0"/>
           </a:p>
@@ -1803,6 +1684,13 @@
             <a:prstDash val="solid"/>
           </a:ln>
         </p:spPr>
+        <p:txBody>
+          <a:bodyPr/>
+          <a:lstStyle/>
+          <a:p>
+            <a:endParaRPr lang="en-IN"/>
+          </a:p>
+        </p:txBody>
       </p:sp>
       <p:sp>
         <p:nvSpPr>
@@ -1825,7 +1713,7 @@
           <a:bodyPr wrap="square" lIns="0" tIns="0" rIns="0" bIns="0" rtlCol="0" anchor="t"/>
           <a:lstStyle/>
           <a:p>
-            <a:pPr indent="0" marL="0">
+            <a:pPr marL="0" indent="0">
               <a:buNone/>
             </a:pPr>
             <a:r>
@@ -1861,7 +1749,7 @@
           <a:bodyPr wrap="square" lIns="0" tIns="0" rIns="0" bIns="0" rtlCol="0" anchor="t"/>
           <a:lstStyle/>
           <a:p>
-            <a:pPr indent="0" marL="0">
+            <a:pPr marL="0" indent="0">
               <a:buNone/>
             </a:pPr>
             <a:r>
@@ -1875,7 +1763,7 @@
             <a:endParaRPr lang="en-US" sz="1600" dirty="0"/>
           </a:p>
           <a:p>
-            <a:pPr indent="0" marL="0">
+            <a:pPr marL="0" indent="0">
               <a:buNone/>
             </a:pPr>
             <a:r>
@@ -1911,7 +1799,7 @@
           <a:bodyPr wrap="square" lIns="0" tIns="0" rIns="0" bIns="0" rtlCol="0" anchor="t"/>
           <a:lstStyle/>
           <a:p>
-            <a:pPr indent="0" marL="0">
+            <a:pPr marL="0" indent="0">
               <a:buNone/>
             </a:pPr>
             <a:r>
@@ -1925,7 +1813,7 @@
             <a:endParaRPr lang="en-US" sz="1600" dirty="0"/>
           </a:p>
           <a:p>
-            <a:pPr indent="0" marL="0">
+            <a:pPr marL="0" indent="0">
               <a:buNone/>
             </a:pPr>
             <a:r>
@@ -1961,7 +1849,7 @@
           <a:bodyPr wrap="square" lIns="0" tIns="0" rIns="0" bIns="0" rtlCol="0" anchor="t"/>
           <a:lstStyle/>
           <a:p>
-            <a:pPr indent="0" marL="0">
+            <a:pPr marL="0" indent="0">
               <a:buNone/>
             </a:pPr>
             <a:r>
@@ -1975,7 +1863,7 @@
             <a:endParaRPr lang="en-US" sz="1600" dirty="0"/>
           </a:p>
           <a:p>
-            <a:pPr indent="0" marL="0">
+            <a:pPr marL="0" indent="0">
               <a:buNone/>
             </a:pPr>
             <a:r>
@@ -2011,7 +1899,7 @@
           <a:bodyPr wrap="square" lIns="0" tIns="0" rIns="0" bIns="0" rtlCol="0" anchor="t"/>
           <a:lstStyle/>
           <a:p>
-            <a:pPr indent="0" marL="0">
+            <a:pPr marL="0" indent="0">
               <a:buNone/>
             </a:pPr>
             <a:r>
@@ -2025,7 +1913,7 @@
             <a:endParaRPr lang="en-US" sz="1600" dirty="0"/>
           </a:p>
           <a:p>
-            <a:pPr indent="0" marL="0">
+            <a:pPr marL="0" indent="0">
               <a:buNone/>
             </a:pPr>
             <a:r>
@@ -2061,7 +1949,7 @@
           <a:bodyPr wrap="square" lIns="0" tIns="0" rIns="0" bIns="0" rtlCol="0" anchor="ctr"/>
           <a:lstStyle/>
           <a:p>
-            <a:pPr indent="0" marL="0">
+            <a:pPr marL="0" indent="0">
               <a:buNone/>
             </a:pPr>
             <a:r>
@@ -2104,9 +1992,11 @@
       <p:sp>
         <p:nvSpPr>
           <p:cNvPr id="2" name="Text 0"/>
-          <p:cNvSpPr/>
+          <p:cNvSpPr>
+            <a:spLocks noGrp="1"/>
+          </p:cNvSpPr>
           <p:nvPr>
-            <p:ph idx="100" type="title" hasCustomPrompt="1"/>
+            <p:ph type="title" idx="100" hasCustomPrompt="1"/>
           </p:nvPr>
         </p:nvSpPr>
         <p:spPr>
@@ -2124,7 +2014,7 @@
           <a:bodyPr wrap="square" lIns="0" tIns="0" rIns="0" bIns="0" rtlCol="0" anchor="ctr"/>
           <a:lstStyle/>
           <a:p>
-            <a:pPr algn="l" indent="0" marL="0">
+            <a:pPr marL="0" indent="0" algn="l">
               <a:buNone/>
             </a:pPr>
             <a:r>
@@ -2165,6 +2055,13 @@
             <a:prstDash val="solid"/>
           </a:ln>
         </p:spPr>
+        <p:txBody>
+          <a:bodyPr/>
+          <a:lstStyle/>
+          <a:p>
+            <a:endParaRPr lang="en-IN"/>
+          </a:p>
+        </p:txBody>
       </p:sp>
       <p:sp>
         <p:nvSpPr>
@@ -2187,7 +2084,7 @@
           <a:bodyPr wrap="square" lIns="0" tIns="0" rIns="0" bIns="0" rtlCol="0" anchor="t"/>
           <a:lstStyle/>
           <a:p>
-            <a:pPr indent="0" marL="0">
+            <a:pPr marL="0" indent="0">
               <a:buNone/>
             </a:pPr>
             <a:r>
@@ -2201,7 +2098,7 @@
             <a:endParaRPr lang="en-US" sz="2000" dirty="0"/>
           </a:p>
           <a:p>
-            <a:pPr indent="0" marL="0">
+            <a:pPr marL="0" indent="0">
               <a:spcBef>
                 <a:spcPts val="800"/>
               </a:spcBef>
@@ -2218,7 +2115,7 @@
             <a:endParaRPr lang="en-US" sz="2000" dirty="0"/>
           </a:p>
           <a:p>
-            <a:pPr indent="0" marL="0">
+            <a:pPr marL="0" indent="0">
               <a:spcBef>
                 <a:spcPts val="1000"/>
               </a:spcBef>
@@ -2262,6 +2159,13 @@
             <a:prstDash val="solid"/>
           </a:ln>
         </p:spPr>
+        <p:txBody>
+          <a:bodyPr/>
+          <a:lstStyle/>
+          <a:p>
+            <a:endParaRPr lang="en-IN"/>
+          </a:p>
+        </p:txBody>
       </p:sp>
       <p:sp>
         <p:nvSpPr>
@@ -2284,7 +2188,7 @@
           <a:bodyPr wrap="square" lIns="0" tIns="0" rIns="0" bIns="0" rtlCol="0" anchor="t"/>
           <a:lstStyle/>
           <a:p>
-            <a:pPr indent="0" marL="0">
+            <a:pPr marL="0" indent="0">
               <a:buNone/>
             </a:pPr>
             <a:r>
@@ -2298,7 +2202,7 @@
             <a:endParaRPr lang="en-US" sz="2000" dirty="0"/>
           </a:p>
           <a:p>
-            <a:pPr indent="0" marL="0">
+            <a:pPr marL="0" indent="0">
               <a:spcBef>
                 <a:spcPts val="800"/>
               </a:spcBef>
@@ -2315,7 +2219,7 @@
             <a:endParaRPr lang="en-US" sz="2000" dirty="0"/>
           </a:p>
           <a:p>
-            <a:pPr indent="0" marL="0">
+            <a:pPr marL="0" indent="0">
               <a:spcBef>
                 <a:spcPts val="1000"/>
               </a:spcBef>
@@ -2359,6 +2263,13 @@
             <a:prstDash val="solid"/>
           </a:ln>
         </p:spPr>
+        <p:txBody>
+          <a:bodyPr/>
+          <a:lstStyle/>
+          <a:p>
+            <a:endParaRPr lang="en-IN"/>
+          </a:p>
+        </p:txBody>
       </p:sp>
       <p:sp>
         <p:nvSpPr>
@@ -2381,7 +2292,7 @@
           <a:bodyPr wrap="square" lIns="0" tIns="0" rIns="0" bIns="0" rtlCol="0" anchor="t"/>
           <a:lstStyle/>
           <a:p>
-            <a:pPr indent="0" marL="0">
+            <a:pPr marL="0" indent="0">
               <a:buNone/>
             </a:pPr>
             <a:r>
@@ -2395,7 +2306,7 @@
             <a:endParaRPr lang="en-US" sz="2000" dirty="0"/>
           </a:p>
           <a:p>
-            <a:pPr indent="0" marL="0">
+            <a:pPr marL="0" indent="0">
               <a:spcBef>
                 <a:spcPts val="800"/>
               </a:spcBef>
@@ -2412,7 +2323,7 @@
             <a:endParaRPr lang="en-US" sz="2000" dirty="0"/>
           </a:p>
           <a:p>
-            <a:pPr indent="0" marL="0">
+            <a:pPr marL="0" indent="0">
               <a:spcBef>
                 <a:spcPts val="1000"/>
               </a:spcBef>
@@ -2456,6 +2367,13 @@
             <a:prstDash val="solid"/>
           </a:ln>
         </p:spPr>
+        <p:txBody>
+          <a:bodyPr/>
+          <a:lstStyle/>
+          <a:p>
+            <a:endParaRPr lang="en-IN"/>
+          </a:p>
+        </p:txBody>
       </p:sp>
       <p:sp>
         <p:nvSpPr>
@@ -2478,7 +2396,7 @@
           <a:bodyPr wrap="square" lIns="0" tIns="0" rIns="0" bIns="0" rtlCol="0" anchor="ctr"/>
           <a:lstStyle/>
           <a:p>
-            <a:pPr indent="0" marL="0">
+            <a:pPr marL="0" indent="0">
               <a:buNone/>
             </a:pPr>
             <a:r>
@@ -2514,7 +2432,7 @@
           <a:bodyPr wrap="square" lIns="0" tIns="0" rIns="0" bIns="0" rtlCol="0" anchor="ctr"/>
           <a:lstStyle/>
           <a:p>
-            <a:pPr indent="0" marL="0">
+            <a:pPr marL="0" indent="0">
               <a:buNone/>
             </a:pPr>
             <a:r>
@@ -2525,9 +2443,6 @@
               </a:rPr>
               <a:t>The </a:t>
             </a:r>
-            <a:pPr indent="0" marL="0">
-              <a:buNone/>
-            </a:pPr>
             <a:r>
               <a:rPr lang="en-US" sz="1600" b="1" dirty="0">
                 <a:solidFill>
@@ -2536,9 +2451,6 @@
               </a:rPr>
               <a:t>complete</a:t>
             </a:r>
-            <a:pPr indent="0" marL="0">
-              <a:buNone/>
-            </a:pPr>
             <a:r>
               <a:rPr lang="en-US" sz="1600" dirty="0">
                 <a:solidFill>
@@ -2547,9 +2459,6 @@
               </a:rPr>
               <a:t> open MusicBrainz export, not a crawl · </a:t>
             </a:r>
-            <a:pPr indent="0" marL="0">
-              <a:buNone/>
-            </a:pPr>
             <a:r>
               <a:rPr lang="en-US" sz="1600" b="1" dirty="0">
                 <a:solidFill>
@@ -2558,9 +2467,6 @@
               </a:rPr>
               <a:t>typed credits</a:t>
             </a:r>
-            <a:pPr indent="0" marL="0">
-              <a:buNone/>
-            </a:pPr>
             <a:r>
               <a:rPr lang="en-US" sz="1600" dirty="0">
                 <a:solidFill>
@@ -2569,9 +2475,6 @@
               </a:rPr>
               <a:t>: billed, featured, producer, performer · a </a:t>
             </a:r>
-            <a:pPr indent="0" marL="0">
-              <a:buNone/>
-            </a:pPr>
             <a:r>
               <a:rPr lang="en-US" sz="1600" b="1" dirty="0">
                 <a:solidFill>
@@ -2580,9 +2483,6 @@
               </a:rPr>
               <a:t>bridge score</a:t>
             </a:r>
-            <a:pPr indent="0" marL="0">
-              <a:buNone/>
-            </a:pPr>
             <a:r>
               <a:rPr lang="en-US" sz="1600" dirty="0">
                 <a:solidFill>
@@ -2616,7 +2516,7 @@
           <a:bodyPr wrap="square" lIns="0" tIns="0" rIns="0" bIns="0" rtlCol="0" anchor="ctr"/>
           <a:lstStyle/>
           <a:p>
-            <a:pPr indent="0" marL="0">
+            <a:pPr marL="0" indent="0">
               <a:buNone/>
             </a:pPr>
             <a:r>
@@ -2651,7 +2551,7 @@
           </a:prstGeom>
           <a:extLst>
             <a:ext uri="{C572A759-6A51-4108-AA02-DFA0A04FC94B}">
-              <ma14:wrappingTextBoxFlag xmlns:ma14="http://schemas.microsoft.com/office/mac/drawingml/2011/main" val="0"/>
+              <ma14:wrappingTextBoxFlag xmlns:ma14="http://schemas.microsoft.com/office/mac/drawingml/2011/main" xmlns="" val="0"/>
             </a:ext>
           </a:extLst>
         </p:spPr>
@@ -2669,7 +2569,7 @@
           <a:p>
             <a:pPr algn="r"/>
             <a:fld id="{F7021451-1387-4CA6-816F-3879F97B5CBC}" type="slidenum">
-              <a:rPr b="0" lang="en-US"/>
+              <a:rPr lang="en-US" b="0"/>
               <a:t>2</a:t>
             </a:fld>
             <a:endParaRPr lang="en-US"/>
@@ -2704,9 +2604,11 @@
       <p:sp>
         <p:nvSpPr>
           <p:cNvPr id="2" name="Text 0"/>
-          <p:cNvSpPr/>
+          <p:cNvSpPr>
+            <a:spLocks noGrp="1"/>
+          </p:cNvSpPr>
           <p:nvPr>
-            <p:ph idx="100" type="title" hasCustomPrompt="1"/>
+            <p:ph type="title" idx="100" hasCustomPrompt="1"/>
           </p:nvPr>
         </p:nvSpPr>
         <p:spPr>
@@ -2724,7 +2626,7 @@
           <a:bodyPr wrap="square" lIns="0" tIns="0" rIns="0" bIns="0" rtlCol="0" anchor="ctr"/>
           <a:lstStyle/>
           <a:p>
-            <a:pPr algn="l" indent="0" marL="0">
+            <a:pPr marL="0" indent="0" algn="l">
               <a:buNone/>
             </a:pPr>
             <a:r>
@@ -2765,6 +2667,13 @@
             <a:prstDash val="solid"/>
           </a:ln>
         </p:spPr>
+        <p:txBody>
+          <a:bodyPr/>
+          <a:lstStyle/>
+          <a:p>
+            <a:endParaRPr lang="en-IN"/>
+          </a:p>
+        </p:txBody>
       </p:sp>
       <p:sp>
         <p:nvSpPr>
@@ -2787,7 +2696,7 @@
           <a:bodyPr wrap="square" lIns="0" tIns="0" rIns="0" bIns="0" rtlCol="0" anchor="ctr"/>
           <a:lstStyle/>
           <a:p>
-            <a:pPr indent="0" marL="0">
+            <a:pPr marL="0" indent="0">
               <a:buNone/>
             </a:pPr>
             <a:r>
@@ -2801,7 +2710,7 @@
             <a:endParaRPr lang="en-US" sz="1800" dirty="0"/>
           </a:p>
           <a:p>
-            <a:pPr indent="0" marL="0">
+            <a:pPr marL="0" indent="0">
               <a:spcBef>
                 <a:spcPts val="400"/>
               </a:spcBef>
@@ -2818,7 +2727,7 @@
             <a:endParaRPr lang="en-US" sz="1800" dirty="0"/>
           </a:p>
           <a:p>
-            <a:pPr indent="0" marL="0">
+            <a:pPr marL="0" indent="0">
               <a:buNone/>
             </a:pPr>
             <a:r>
@@ -2857,6 +2766,13 @@
             <a:prstDash val="solid"/>
           </a:ln>
         </p:spPr>
+        <p:txBody>
+          <a:bodyPr/>
+          <a:lstStyle/>
+          <a:p>
+            <a:endParaRPr lang="en-IN"/>
+          </a:p>
+        </p:txBody>
       </p:sp>
       <p:sp>
         <p:nvSpPr>
@@ -2884,6 +2800,13 @@
             <a:prstDash val="solid"/>
           </a:ln>
         </p:spPr>
+        <p:txBody>
+          <a:bodyPr/>
+          <a:lstStyle/>
+          <a:p>
+            <a:endParaRPr lang="en-IN"/>
+          </a:p>
+        </p:txBody>
       </p:sp>
       <p:sp>
         <p:nvSpPr>
@@ -2906,7 +2829,7 @@
           <a:bodyPr wrap="square" lIns="0" tIns="0" rIns="0" bIns="0" rtlCol="0" anchor="ctr"/>
           <a:lstStyle/>
           <a:p>
-            <a:pPr indent="0" marL="0">
+            <a:pPr marL="0" indent="0">
               <a:buNone/>
             </a:pPr>
             <a:r>
@@ -2920,7 +2843,7 @@
             <a:endParaRPr lang="en-US" sz="1800" dirty="0"/>
           </a:p>
           <a:p>
-            <a:pPr indent="0" marL="0">
+            <a:pPr marL="0" indent="0">
               <a:spcBef>
                 <a:spcPts val="400"/>
               </a:spcBef>
@@ -2937,7 +2860,7 @@
             <a:endParaRPr lang="en-US" sz="1800" dirty="0"/>
           </a:p>
           <a:p>
-            <a:pPr indent="0" marL="0">
+            <a:pPr marL="0" indent="0">
               <a:buNone/>
             </a:pPr>
             <a:r>
@@ -2976,6 +2899,13 @@
             <a:prstDash val="solid"/>
           </a:ln>
         </p:spPr>
+        <p:txBody>
+          <a:bodyPr/>
+          <a:lstStyle/>
+          <a:p>
+            <a:endParaRPr lang="en-IN"/>
+          </a:p>
+        </p:txBody>
       </p:sp>
       <p:sp>
         <p:nvSpPr>
@@ -3003,6 +2933,13 @@
             <a:prstDash val="solid"/>
           </a:ln>
         </p:spPr>
+        <p:txBody>
+          <a:bodyPr/>
+          <a:lstStyle/>
+          <a:p>
+            <a:endParaRPr lang="en-IN"/>
+          </a:p>
+        </p:txBody>
       </p:sp>
       <p:sp>
         <p:nvSpPr>
@@ -3025,7 +2962,7 @@
           <a:bodyPr wrap="square" lIns="0" tIns="0" rIns="0" bIns="0" rtlCol="0" anchor="ctr"/>
           <a:lstStyle/>
           <a:p>
-            <a:pPr indent="0" marL="0">
+            <a:pPr marL="0" indent="0">
               <a:buNone/>
             </a:pPr>
             <a:r>
@@ -3039,7 +2976,7 @@
             <a:endParaRPr lang="en-US" sz="1800" dirty="0"/>
           </a:p>
           <a:p>
-            <a:pPr indent="0" marL="0">
+            <a:pPr marL="0" indent="0">
               <a:spcBef>
                 <a:spcPts val="400"/>
               </a:spcBef>
@@ -3056,7 +2993,7 @@
             <a:endParaRPr lang="en-US" sz="1800" dirty="0"/>
           </a:p>
           <a:p>
-            <a:pPr indent="0" marL="0">
+            <a:pPr marL="0" indent="0">
               <a:buNone/>
             </a:pPr>
             <a:r>
@@ -3095,6 +3032,13 @@
             <a:prstDash val="solid"/>
           </a:ln>
         </p:spPr>
+        <p:txBody>
+          <a:bodyPr/>
+          <a:lstStyle/>
+          <a:p>
+            <a:endParaRPr lang="en-IN"/>
+          </a:p>
+        </p:txBody>
       </p:sp>
       <p:sp>
         <p:nvSpPr>
@@ -3122,6 +3066,13 @@
             <a:prstDash val="solid"/>
           </a:ln>
         </p:spPr>
+        <p:txBody>
+          <a:bodyPr/>
+          <a:lstStyle/>
+          <a:p>
+            <a:endParaRPr lang="en-IN"/>
+          </a:p>
+        </p:txBody>
       </p:sp>
       <p:sp>
         <p:nvSpPr>
@@ -3144,7 +3095,7 @@
           <a:bodyPr wrap="square" lIns="0" tIns="0" rIns="0" bIns="0" rtlCol="0" anchor="ctr"/>
           <a:lstStyle/>
           <a:p>
-            <a:pPr indent="0" marL="0">
+            <a:pPr marL="0" indent="0">
               <a:buNone/>
             </a:pPr>
             <a:r>
@@ -3158,7 +3109,7 @@
             <a:endParaRPr lang="en-US" sz="1800" dirty="0"/>
           </a:p>
           <a:p>
-            <a:pPr indent="0" marL="0">
+            <a:pPr marL="0" indent="0">
               <a:spcBef>
                 <a:spcPts val="400"/>
               </a:spcBef>
@@ -3175,7 +3126,7 @@
             <a:endParaRPr lang="en-US" sz="1800" dirty="0"/>
           </a:p>
           <a:p>
-            <a:pPr indent="0" marL="0">
+            <a:pPr marL="0" indent="0">
               <a:buNone/>
             </a:pPr>
             <a:r>
@@ -3211,7 +3162,7 @@
           <a:bodyPr wrap="square" lIns="0" tIns="0" rIns="0" bIns="0" rtlCol="0" anchor="ctr"/>
           <a:lstStyle/>
           <a:p>
-            <a:pPr indent="0" marL="0">
+            <a:pPr marL="0" indent="0">
               <a:buNone/>
             </a:pPr>
             <a:r>
@@ -3323,7 +3274,7 @@
           <a:bodyPr wrap="square" lIns="0" tIns="0" rIns="0" bIns="0" rtlCol="0" anchor="ctr"/>
           <a:lstStyle/>
           <a:p>
-            <a:pPr indent="0" marL="0">
+            <a:pPr marL="0" indent="0">
               <a:buNone/>
             </a:pPr>
             <a:r>
@@ -3453,7 +3404,7 @@
           <a:bodyPr wrap="square" lIns="0" tIns="0" rIns="0" bIns="0" rtlCol="0" anchor="ctr"/>
           <a:lstStyle/>
           <a:p>
-            <a:pPr indent="0" marL="0">
+            <a:pPr marL="0" indent="0">
               <a:buNone/>
             </a:pPr>
             <a:r>
@@ -3488,7 +3439,7 @@
           </a:prstGeom>
           <a:extLst>
             <a:ext uri="{C572A759-6A51-4108-AA02-DFA0A04FC94B}">
-              <ma14:wrappingTextBoxFlag xmlns:ma14="http://schemas.microsoft.com/office/mac/drawingml/2011/main" val="0"/>
+              <ma14:wrappingTextBoxFlag xmlns:ma14="http://schemas.microsoft.com/office/mac/drawingml/2011/main" xmlns="" val="0"/>
             </a:ext>
           </a:extLst>
         </p:spPr>
@@ -3506,7 +3457,7 @@
           <a:p>
             <a:pPr algn="r"/>
             <a:fld id="{F7021451-1387-4CA6-816F-3879F97B5CBC}" type="slidenum">
-              <a:rPr b="0" lang="en-US"/>
+              <a:rPr lang="en-US" b="0"/>
               <a:t>3</a:t>
             </a:fld>
             <a:endParaRPr lang="en-US"/>
@@ -3541,9 +3492,11 @@
       <p:sp>
         <p:nvSpPr>
           <p:cNvPr id="2" name="Text 0"/>
-          <p:cNvSpPr/>
+          <p:cNvSpPr>
+            <a:spLocks noGrp="1"/>
+          </p:cNvSpPr>
           <p:nvPr>
-            <p:ph idx="100" type="title" hasCustomPrompt="1"/>
+            <p:ph type="title" idx="100" hasCustomPrompt="1"/>
           </p:nvPr>
         </p:nvSpPr>
         <p:spPr>
@@ -3561,7 +3514,7 @@
           <a:bodyPr wrap="square" lIns="0" tIns="0" rIns="0" bIns="0" rtlCol="0" anchor="ctr"/>
           <a:lstStyle/>
           <a:p>
-            <a:pPr algn="l" indent="0" marL="0">
+            <a:pPr marL="0" indent="0" algn="l">
               <a:buNone/>
             </a:pPr>
             <a:r>
@@ -3602,6 +3555,13 @@
             <a:prstDash val="dash"/>
           </a:ln>
         </p:spPr>
+        <p:txBody>
+          <a:bodyPr/>
+          <a:lstStyle/>
+          <a:p>
+            <a:endParaRPr lang="en-IN"/>
+          </a:p>
+        </p:txBody>
       </p:sp>
       <p:sp>
         <p:nvSpPr>
@@ -3624,32 +3584,17 @@
           <a:bodyPr wrap="square" lIns="0" tIns="0" rIns="0" bIns="0" rtlCol="0" anchor="ctr"/>
           <a:lstStyle/>
           <a:p>
-            <a:pPr algn="ctr" indent="0" marL="0">
-              <a:buNone/>
-            </a:pPr>
-            <a:r>
-              <a:rPr lang="en-US" sz="2200" b="1" dirty="0">
-                <a:solidFill>
-                  <a:schemeClr val="bg2"/>
-                </a:solidFill>
-              </a:rPr>
-              <a:t>Demo video</a:t>
-            </a:r>
-            <a:endParaRPr lang="en-US" sz="2200" dirty="0"/>
-          </a:p>
-          <a:p>
-            <a:pPr algn="ctr" indent="0" marL="0">
-              <a:buNone/>
-            </a:pPr>
-            <a:r>
-              <a:rPr lang="en-US" sz="1500" dirty="0">
-                <a:solidFill>
-                  <a:schemeClr val="bg2"/>
-                </a:solidFill>
-              </a:rPr>
-              <a:t>Insert › Video, then place it over this frame</a:t>
-            </a:r>
-            <a:endParaRPr lang="en-US" sz="2200" dirty="0"/>
+            <a:pPr marL="0" indent="0" algn="ctr">
+              <a:buNone/>
+            </a:pPr>
+            <a:r>
+              <a:rPr lang="en-US" sz="2200" dirty="0">
+                <a:solidFill>
+                  <a:schemeClr val="bg1"/>
+                </a:solidFill>
+              </a:rPr>
+              <a:t>See the live demo</a:t>
+            </a:r>
           </a:p>
         </p:txBody>
       </p:sp>
@@ -3674,7 +3619,7 @@
           <a:bodyPr wrap="square" lIns="0" tIns="0" rIns="0" bIns="0" rtlCol="0" anchor="ctr"/>
           <a:lstStyle/>
           <a:p>
-            <a:pPr indent="0" marL="0">
+            <a:pPr marL="0" indent="0">
               <a:buNone/>
             </a:pPr>
             <a:r>
@@ -3716,7 +3661,7 @@
               </a:spcAft>
               <a:buSzPct val="100000"/>
               <a:buFont typeface="+mj-lt"/>
-              <a:buAutoNum type="arabicPeriod" startAt="1"/>
+              <a:buAutoNum type="arabicPeriod"/>
             </a:pPr>
             <a:r>
               <a:rPr lang="en-US" sz="1600" dirty="0">
@@ -3735,7 +3680,7 @@
               </a:spcAft>
               <a:buSzPct val="100000"/>
               <a:buFont typeface="+mj-lt"/>
-              <a:buAutoNum type="arabicPeriod" startAt="1"/>
+              <a:buAutoNum type="arabicPeriod"/>
             </a:pPr>
             <a:r>
               <a:rPr lang="en-US" sz="1600" dirty="0">
@@ -3754,7 +3699,7 @@
               </a:spcAft>
               <a:buSzPct val="100000"/>
               <a:buFont typeface="+mj-lt"/>
-              <a:buAutoNum type="arabicPeriod" startAt="1"/>
+              <a:buAutoNum type="arabicPeriod"/>
             </a:pPr>
             <a:r>
               <a:rPr lang="en-US" sz="1600" dirty="0">
@@ -3773,7 +3718,7 @@
               </a:spcAft>
               <a:buSzPct val="100000"/>
               <a:buFont typeface="+mj-lt"/>
-              <a:buAutoNum type="arabicPeriod" startAt="1"/>
+              <a:buAutoNum type="arabicPeriod"/>
             </a:pPr>
             <a:r>
               <a:rPr lang="en-US" sz="1600" dirty="0">
@@ -3792,7 +3737,7 @@
               </a:spcAft>
               <a:buSzPct val="100000"/>
               <a:buFont typeface="+mj-lt"/>
-              <a:buAutoNum type="arabicPeriod" startAt="1"/>
+              <a:buAutoNum type="arabicPeriod"/>
             </a:pPr>
             <a:r>
               <a:rPr lang="en-US" sz="1600" dirty="0">
@@ -3811,7 +3756,7 @@
               </a:spcAft>
               <a:buSzPct val="100000"/>
               <a:buFont typeface="+mj-lt"/>
-              <a:buAutoNum type="arabicPeriod" startAt="1"/>
+              <a:buAutoNum type="arabicPeriod"/>
             </a:pPr>
             <a:r>
               <a:rPr lang="en-US" sz="1600" dirty="0">
@@ -3830,7 +3775,7 @@
               </a:spcAft>
               <a:buSzPct val="100000"/>
               <a:buFont typeface="+mj-lt"/>
-              <a:buAutoNum type="arabicPeriod" startAt="1"/>
+              <a:buAutoNum type="arabicPeriod"/>
             </a:pPr>
             <a:r>
               <a:rPr lang="en-US" sz="1600" dirty="0">
@@ -3865,7 +3810,7 @@
           <a:bodyPr wrap="square" lIns="0" tIns="0" rIns="0" bIns="0" rtlCol="0" anchor="ctr"/>
           <a:lstStyle/>
           <a:p>
-            <a:pPr indent="0" marL="0">
+            <a:pPr marL="0" indent="0">
               <a:buNone/>
             </a:pPr>
             <a:r>
@@ -3900,7 +3845,7 @@
           </a:prstGeom>
           <a:extLst>
             <a:ext uri="{C572A759-6A51-4108-AA02-DFA0A04FC94B}">
-              <ma14:wrappingTextBoxFlag xmlns:ma14="http://schemas.microsoft.com/office/mac/drawingml/2011/main" val="0"/>
+              <ma14:wrappingTextBoxFlag xmlns:ma14="http://schemas.microsoft.com/office/mac/drawingml/2011/main" xmlns="" val="0"/>
             </a:ext>
           </a:extLst>
         </p:spPr>
@@ -3918,7 +3863,7 @@
           <a:p>
             <a:pPr algn="r"/>
             <a:fld id="{F7021451-1387-4CA6-816F-3879F97B5CBC}" type="slidenum">
-              <a:rPr b="0" lang="en-US"/>
+              <a:rPr lang="en-US" b="0"/>
               <a:t>4</a:t>
             </a:fld>
             <a:endParaRPr lang="en-US"/>
@@ -3953,9 +3898,11 @@
       <p:sp>
         <p:nvSpPr>
           <p:cNvPr id="2" name="Text 0"/>
-          <p:cNvSpPr/>
+          <p:cNvSpPr>
+            <a:spLocks noGrp="1"/>
+          </p:cNvSpPr>
           <p:nvPr>
-            <p:ph idx="100" type="title" hasCustomPrompt="1"/>
+            <p:ph type="title" idx="100" hasCustomPrompt="1"/>
           </p:nvPr>
         </p:nvSpPr>
         <p:spPr>
@@ -3973,7 +3920,7 @@
           <a:bodyPr wrap="square" lIns="0" tIns="0" rIns="0" bIns="0" rtlCol="0" anchor="ctr"/>
           <a:lstStyle/>
           <a:p>
-            <a:pPr algn="l" indent="0" marL="0">
+            <a:pPr marL="0" indent="0" algn="l">
               <a:buNone/>
             </a:pPr>
             <a:r>
@@ -4014,6 +3961,13 @@
             <a:prstDash val="solid"/>
           </a:ln>
         </p:spPr>
+        <p:txBody>
+          <a:bodyPr/>
+          <a:lstStyle/>
+          <a:p>
+            <a:endParaRPr lang="en-IN"/>
+          </a:p>
+        </p:txBody>
       </p:sp>
       <p:sp>
         <p:nvSpPr>
@@ -4036,7 +3990,7 @@
           <a:bodyPr wrap="square" lIns="0" tIns="0" rIns="0" bIns="0" rtlCol="0" anchor="t"/>
           <a:lstStyle/>
           <a:p>
-            <a:pPr indent="0" marL="0">
+            <a:pPr marL="0" indent="0">
               <a:buNone/>
             </a:pPr>
             <a:r>
@@ -4050,7 +4004,7 @@
             <a:endParaRPr lang="en-US" sz="1400" dirty="0"/>
           </a:p>
           <a:p>
-            <a:pPr indent="0" marL="0">
+            <a:pPr marL="0" indent="0">
               <a:spcBef>
                 <a:spcPts val="400"/>
               </a:spcBef>
@@ -4067,7 +4021,7 @@
             <a:endParaRPr lang="en-US" sz="1400" dirty="0"/>
           </a:p>
           <a:p>
-            <a:pPr indent="0" marL="0">
+            <a:pPr marL="0" indent="0">
               <a:spcBef>
                 <a:spcPts val="600"/>
               </a:spcBef>
@@ -4111,6 +4065,13 @@
             <a:prstDash val="solid"/>
           </a:ln>
         </p:spPr>
+        <p:txBody>
+          <a:bodyPr/>
+          <a:lstStyle/>
+          <a:p>
+            <a:endParaRPr lang="en-IN"/>
+          </a:p>
+        </p:txBody>
       </p:sp>
       <p:sp>
         <p:nvSpPr>
@@ -4133,7 +4094,7 @@
           <a:bodyPr wrap="square" lIns="0" tIns="0" rIns="0" bIns="0" rtlCol="0" anchor="t"/>
           <a:lstStyle/>
           <a:p>
-            <a:pPr indent="0" marL="0">
+            <a:pPr marL="0" indent="0">
               <a:buNone/>
             </a:pPr>
             <a:r>
@@ -4147,7 +4108,7 @@
             <a:endParaRPr lang="en-US" sz="1400" dirty="0"/>
           </a:p>
           <a:p>
-            <a:pPr indent="0" marL="0">
+            <a:pPr marL="0" indent="0">
               <a:spcBef>
                 <a:spcPts val="400"/>
               </a:spcBef>
@@ -4164,7 +4125,7 @@
             <a:endParaRPr lang="en-US" sz="1400" dirty="0"/>
           </a:p>
           <a:p>
-            <a:pPr indent="0" marL="0">
+            <a:pPr marL="0" indent="0">
               <a:spcBef>
                 <a:spcPts val="600"/>
               </a:spcBef>
@@ -4208,6 +4169,13 @@
             <a:prstDash val="solid"/>
           </a:ln>
         </p:spPr>
+        <p:txBody>
+          <a:bodyPr/>
+          <a:lstStyle/>
+          <a:p>
+            <a:endParaRPr lang="en-IN"/>
+          </a:p>
+        </p:txBody>
       </p:sp>
       <p:sp>
         <p:nvSpPr>
@@ -4230,7 +4198,7 @@
           <a:bodyPr wrap="square" lIns="0" tIns="0" rIns="0" bIns="0" rtlCol="0" anchor="t"/>
           <a:lstStyle/>
           <a:p>
-            <a:pPr indent="0" marL="0">
+            <a:pPr marL="0" indent="0">
               <a:buNone/>
             </a:pPr>
             <a:r>
@@ -4244,7 +4212,7 @@
             <a:endParaRPr lang="en-US" sz="1400" dirty="0"/>
           </a:p>
           <a:p>
-            <a:pPr indent="0" marL="0">
+            <a:pPr marL="0" indent="0">
               <a:spcBef>
                 <a:spcPts val="400"/>
               </a:spcBef>
@@ -4261,7 +4229,7 @@
             <a:endParaRPr lang="en-US" sz="1400" dirty="0"/>
           </a:p>
           <a:p>
-            <a:pPr indent="0" marL="0">
+            <a:pPr marL="0" indent="0">
               <a:spcBef>
                 <a:spcPts val="600"/>
               </a:spcBef>
@@ -4305,6 +4273,13 @@
             <a:prstDash val="solid"/>
           </a:ln>
         </p:spPr>
+        <p:txBody>
+          <a:bodyPr/>
+          <a:lstStyle/>
+          <a:p>
+            <a:endParaRPr lang="en-IN"/>
+          </a:p>
+        </p:txBody>
       </p:sp>
       <p:sp>
         <p:nvSpPr>
@@ -4327,7 +4302,7 @@
           <a:bodyPr wrap="square" lIns="0" tIns="0" rIns="0" bIns="0" rtlCol="0" anchor="t"/>
           <a:lstStyle/>
           <a:p>
-            <a:pPr indent="0" marL="0">
+            <a:pPr marL="0" indent="0">
               <a:buNone/>
             </a:pPr>
             <a:r>
@@ -4341,7 +4316,7 @@
             <a:endParaRPr lang="en-US" sz="1400" dirty="0"/>
           </a:p>
           <a:p>
-            <a:pPr indent="0" marL="0">
+            <a:pPr marL="0" indent="0">
               <a:spcBef>
                 <a:spcPts val="400"/>
               </a:spcBef>
@@ -4358,7 +4333,7 @@
             <a:endParaRPr lang="en-US" sz="1400" dirty="0"/>
           </a:p>
           <a:p>
-            <a:pPr indent="0" marL="0">
+            <a:pPr marL="0" indent="0">
               <a:spcBef>
                 <a:spcPts val="600"/>
               </a:spcBef>
@@ -4402,6 +4377,13 @@
             <a:prstDash val="solid"/>
           </a:ln>
         </p:spPr>
+        <p:txBody>
+          <a:bodyPr/>
+          <a:lstStyle/>
+          <a:p>
+            <a:endParaRPr lang="en-IN"/>
+          </a:p>
+        </p:txBody>
       </p:sp>
       <p:sp>
         <p:nvSpPr>
@@ -4424,7 +4406,7 @@
           <a:bodyPr wrap="square" lIns="0" tIns="0" rIns="0" bIns="0" rtlCol="0" anchor="ctr"/>
           <a:lstStyle/>
           <a:p>
-            <a:pPr indent="0" marL="0">
+            <a:pPr marL="0" indent="0">
               <a:buNone/>
             </a:pPr>
             <a:r>
@@ -4460,7 +4442,7 @@
           <a:bodyPr wrap="square" lIns="0" tIns="0" rIns="0" bIns="0" rtlCol="0" anchor="ctr"/>
           <a:lstStyle/>
           <a:p>
-            <a:pPr indent="0" marL="0">
+            <a:pPr marL="0" indent="0">
               <a:buNone/>
             </a:pPr>
             <a:r>
@@ -4496,7 +4478,7 @@
           <a:bodyPr wrap="square" lIns="0" tIns="0" rIns="0" bIns="0" rtlCol="0" anchor="ctr"/>
           <a:lstStyle/>
           <a:p>
-            <a:pPr indent="0" marL="0">
+            <a:pPr marL="0" indent="0">
               <a:buNone/>
             </a:pPr>
             <a:r>
@@ -4531,7 +4513,7 @@
           </a:prstGeom>
           <a:extLst>
             <a:ext uri="{C572A759-6A51-4108-AA02-DFA0A04FC94B}">
-              <ma14:wrappingTextBoxFlag xmlns:ma14="http://schemas.microsoft.com/office/mac/drawingml/2011/main" val="0"/>
+              <ma14:wrappingTextBoxFlag xmlns:ma14="http://schemas.microsoft.com/office/mac/drawingml/2011/main" xmlns="" val="0"/>
             </a:ext>
           </a:extLst>
         </p:spPr>
@@ -4549,8 +4531,514 @@
           <a:p>
             <a:pPr algn="r"/>
             <a:fld id="{F7021451-1387-4CA6-816F-3879F97B5CBC}" type="slidenum">
-              <a:rPr b="0" lang="en-US"/>
+              <a:rPr lang="en-US" b="0"/>
               <a:t>5</a:t>
+            </a:fld>
+            <a:endParaRPr lang="en-US"/>
+          </a:p>
+        </p:txBody>
+      </p:sp>
+    </p:spTree>
+  </p:cSld>
+  <p:clrMapOvr>
+    <a:masterClrMapping/>
+  </p:clrMapOvr>
+</p:sld>
+</file>
+
+<file path=ppt/slides/slide6.xml><?xml version="1.0" encoding="utf-8"?>
+<p:sld xmlns:a="http://schemas.openxmlformats.org/drawingml/2006/main" xmlns:p="http://schemas.openxmlformats.org/presentationml/2006/main" xmlns:r="http://schemas.openxmlformats.org/officeDocument/2006/relationships">
+  <p:cSld>
+    <p:spTree>
+      <p:nvGrpSpPr>
+        <p:cNvPr id="1" name=""/>
+        <p:cNvGrpSpPr/>
+        <p:nvPr/>
+      </p:nvGrpSpPr>
+      <p:grpSpPr/>
+      <p:sp>
+        <p:nvSpPr>
+          <p:cNvPr id="2" name="Text 0"/>
+          <p:cNvSpPr>
+            <a:spLocks noGrp="1"/>
+          </p:cNvSpPr>
+          <p:nvPr>
+            <p:ph type="title" idx="100" hasCustomPrompt="1"/>
+          </p:nvPr>
+        </p:nvSpPr>
+        <p:spPr>
+          <a:xfrm>
+            <a:off x="548640" y="365760"/>
+            <a:ext cx="11094415" cy="777240"/>
+          </a:xfrm>
+          <a:prstGeom prst="rect">
+            <a:avLst/>
+          </a:prstGeom>
+          <a:noFill/>
+          <a:ln/>
+        </p:spPr>
+        <p:txBody>
+          <a:bodyPr wrap="square" lIns="0" tIns="0" rIns="0" bIns="0" rtlCol="0" anchor="ctr"/>
+          <a:lstStyle/>
+          <a:p>
+            <a:pPr marL="0" indent="0" algn="l">
+              <a:buNone/>
+            </a:pPr>
+            <a:r>
+              <a:rPr lang="en-US" sz="3600" b="1" dirty="0">
+                <a:solidFill>
+                  <a:schemeClr val="tx1"/>
+                </a:solidFill>
+              </a:rPr>
+              <a:t>Future scope</a:t>
+            </a:r>
+            <a:endParaRPr lang="en-US" sz="3600" dirty="0"/>
+          </a:p>
+        </p:txBody>
+      </p:sp>
+      <p:sp>
+        <p:nvSpPr>
+          <p:cNvPr id="3" name="Scope 1"/>
+          <p:cNvSpPr/>
+          <p:nvPr/>
+        </p:nvSpPr>
+        <p:spPr>
+          <a:xfrm>
+            <a:off x="548640" y="1371600"/>
+            <a:ext cx="3515258" cy="2651760"/>
+          </a:xfrm>
+          <a:prstGeom prst="roundRect">
+            <a:avLst>
+              <a:gd name="adj" fmla="val 4138"/>
+            </a:avLst>
+          </a:prstGeom>
+          <a:solidFill>
+            <a:schemeClr val="bg2"/>
+          </a:solidFill>
+          <a:ln w="12700">
+            <a:solidFill>
+              <a:schemeClr val="bg2"/>
+            </a:solidFill>
+            <a:prstDash val="solid"/>
+          </a:ln>
+        </p:spPr>
+        <p:txBody>
+          <a:bodyPr/>
+          <a:lstStyle/>
+          <a:p>
+            <a:endParaRPr lang="en-IN"/>
+          </a:p>
+        </p:txBody>
+      </p:sp>
+      <p:sp>
+        <p:nvSpPr>
+          <p:cNvPr id="4" name="Scope 1 text"/>
+          <p:cNvSpPr txBox="1"/>
+          <p:nvPr/>
+        </p:nvSpPr>
+        <p:spPr>
+          <a:xfrm>
+            <a:off x="822960" y="1600200"/>
+            <a:ext cx="2966618" cy="2240280"/>
+          </a:xfrm>
+          <a:prstGeom prst="rect">
+            <a:avLst/>
+          </a:prstGeom>
+          <a:noFill/>
+          <a:ln/>
+        </p:spPr>
+        <p:txBody>
+          <a:bodyPr wrap="square" lIns="0" tIns="0" rIns="0" bIns="0" rtlCol="0" anchor="t"/>
+          <a:lstStyle/>
+          <a:p>
+            <a:pPr marL="0" indent="0">
+              <a:buNone/>
+            </a:pPr>
+            <a:r>
+              <a:rPr lang="en-US" sz="2000" b="1" dirty="0">
+                <a:solidFill>
+                  <a:schemeClr val="accent3"/>
+                </a:solidFill>
+              </a:rPr>
+              <a:t>Store</a:t>
+            </a:r>
+            <a:endParaRPr lang="en-US" sz="2000" dirty="0"/>
+          </a:p>
+          <a:p>
+            <a:pPr marL="0" indent="0">
+              <a:spcBef>
+                <a:spcPts val="1000"/>
+              </a:spcBef>
+              <a:buNone/>
+            </a:pPr>
+            <a:r>
+              <a:rPr lang="en-US" sz="1600" dirty="0">
+                <a:solidFill>
+                  <a:schemeClr val="tx2"/>
+                </a:solidFill>
+              </a:rPr>
+              <a:t>Distributed object storage (S3 or HDFS) holding Parquet in an open table format (Apache Iceberg or Delta Lake), partitioned by date and entity type.</a:t>
+            </a:r>
+            <a:endParaRPr lang="en-US" sz="2000" dirty="0"/>
+          </a:p>
+        </p:txBody>
+      </p:sp>
+      <p:sp>
+        <p:nvSpPr>
+          <p:cNvPr id="5" name="Scope 2"/>
+          <p:cNvSpPr/>
+          <p:nvPr/>
+        </p:nvSpPr>
+        <p:spPr>
+          <a:xfrm>
+            <a:off x="4338218" y="1371600"/>
+            <a:ext cx="3515258" cy="2651760"/>
+          </a:xfrm>
+          <a:prstGeom prst="roundRect">
+            <a:avLst>
+              <a:gd name="adj" fmla="val 4138"/>
+            </a:avLst>
+          </a:prstGeom>
+          <a:solidFill>
+            <a:schemeClr val="bg2"/>
+          </a:solidFill>
+          <a:ln w="12700">
+            <a:solidFill>
+              <a:schemeClr val="bg2"/>
+            </a:solidFill>
+            <a:prstDash val="solid"/>
+          </a:ln>
+        </p:spPr>
+        <p:txBody>
+          <a:bodyPr/>
+          <a:lstStyle/>
+          <a:p>
+            <a:endParaRPr lang="en-IN"/>
+          </a:p>
+        </p:txBody>
+      </p:sp>
+      <p:sp>
+        <p:nvSpPr>
+          <p:cNvPr id="6" name="Scope 2 text"/>
+          <p:cNvSpPr txBox="1"/>
+          <p:nvPr/>
+        </p:nvSpPr>
+        <p:spPr>
+          <a:xfrm>
+            <a:off x="4612538" y="1600200"/>
+            <a:ext cx="2966618" cy="2240280"/>
+          </a:xfrm>
+          <a:prstGeom prst="rect">
+            <a:avLst/>
+          </a:prstGeom>
+          <a:noFill/>
+          <a:ln/>
+        </p:spPr>
+        <p:txBody>
+          <a:bodyPr wrap="square" lIns="0" tIns="0" rIns="0" bIns="0" rtlCol="0" anchor="t"/>
+          <a:lstStyle/>
+          <a:p>
+            <a:pPr marL="0" indent="0">
+              <a:buNone/>
+            </a:pPr>
+            <a:r>
+              <a:rPr lang="en-US" sz="2000" b="1" dirty="0">
+                <a:solidFill>
+                  <a:schemeClr val="accent3"/>
+                </a:solidFill>
+              </a:rPr>
+              <a:t>Process</a:t>
+            </a:r>
+            <a:endParaRPr lang="en-US" sz="2000" dirty="0"/>
+          </a:p>
+          <a:p>
+            <a:pPr marL="0" indent="0">
+              <a:spcBef>
+                <a:spcPts val="1000"/>
+              </a:spcBef>
+              <a:buNone/>
+            </a:pPr>
+            <a:r>
+              <a:rPr lang="en-US" sz="1600" dirty="0">
+                <a:solidFill>
+                  <a:schemeClr val="tx2"/>
+                </a:solidFill>
+              </a:rPr>
+              <a:t>Spark on an autoscaling cluster (Kubernetes or YARN): the same DataFrame code with more executors, loading MusicBrainz's live replication packets incrementally instead of full dumps.</a:t>
+            </a:r>
+            <a:endParaRPr lang="en-US" sz="2000" dirty="0"/>
+          </a:p>
+        </p:txBody>
+      </p:sp>
+      <p:sp>
+        <p:nvSpPr>
+          <p:cNvPr id="7" name="Scope 3"/>
+          <p:cNvSpPr/>
+          <p:nvPr/>
+        </p:nvSpPr>
+        <p:spPr>
+          <a:xfrm>
+            <a:off x="8127797" y="1371600"/>
+            <a:ext cx="3515258" cy="2651760"/>
+          </a:xfrm>
+          <a:prstGeom prst="roundRect">
+            <a:avLst>
+              <a:gd name="adj" fmla="val 4138"/>
+            </a:avLst>
+          </a:prstGeom>
+          <a:solidFill>
+            <a:schemeClr val="bg2"/>
+          </a:solidFill>
+          <a:ln w="12700">
+            <a:solidFill>
+              <a:schemeClr val="bg2"/>
+            </a:solidFill>
+            <a:prstDash val="solid"/>
+          </a:ln>
+        </p:spPr>
+        <p:txBody>
+          <a:bodyPr/>
+          <a:lstStyle/>
+          <a:p>
+            <a:endParaRPr lang="en-IN"/>
+          </a:p>
+        </p:txBody>
+      </p:sp>
+      <p:sp>
+        <p:nvSpPr>
+          <p:cNvPr id="8" name="Scope 3 text"/>
+          <p:cNvSpPr txBox="1"/>
+          <p:nvPr/>
+        </p:nvSpPr>
+        <p:spPr>
+          <a:xfrm>
+            <a:off x="8402117" y="1600200"/>
+            <a:ext cx="2966618" cy="2240280"/>
+          </a:xfrm>
+          <a:prstGeom prst="rect">
+            <a:avLst/>
+          </a:prstGeom>
+          <a:noFill/>
+          <a:ln/>
+        </p:spPr>
+        <p:txBody>
+          <a:bodyPr wrap="square" lIns="0" tIns="0" rIns="0" bIns="0" rtlCol="0" anchor="t"/>
+          <a:lstStyle/>
+          <a:p>
+            <a:pPr marL="0" indent="0">
+              <a:buNone/>
+            </a:pPr>
+            <a:r>
+              <a:rPr lang="en-US" sz="2000" b="1" dirty="0">
+                <a:solidFill>
+                  <a:schemeClr val="accent3"/>
+                </a:solidFill>
+              </a:rPr>
+              <a:t>Analyse</a:t>
+            </a:r>
+            <a:endParaRPr lang="en-US" sz="2000" dirty="0"/>
+          </a:p>
+          <a:p>
+            <a:pPr marL="0" indent="0">
+              <a:spcBef>
+                <a:spcPts val="1000"/>
+              </a:spcBef>
+              <a:buNone/>
+            </a:pPr>
+            <a:r>
+              <a:rPr lang="en-US" sz="1600" dirty="0">
+                <a:solidFill>
+                  <a:schemeClr val="tx2"/>
+                </a:solidFill>
+              </a:rPr>
+              <a:t>A single Neo4j server can't hold it: run graph algorithms distributed (GraphFrames or multi-GPU cuGraph) with sampled or approximate measures; keep Neo4j for serving subgraphs.</a:t>
+            </a:r>
+            <a:endParaRPr lang="en-US" sz="2000" dirty="0"/>
+          </a:p>
+        </p:txBody>
+      </p:sp>
+      <p:sp>
+        <p:nvSpPr>
+          <p:cNvPr id="9" name="Key idea band"/>
+          <p:cNvSpPr/>
+          <p:nvPr/>
+        </p:nvSpPr>
+        <p:spPr>
+          <a:xfrm>
+            <a:off x="548640" y="4343400"/>
+            <a:ext cx="11094415" cy="1097280"/>
+          </a:xfrm>
+          <a:prstGeom prst="roundRect">
+            <a:avLst>
+              <a:gd name="adj" fmla="val 10000"/>
+            </a:avLst>
+          </a:prstGeom>
+          <a:solidFill>
+            <a:schemeClr val="tx1"/>
+          </a:solidFill>
+          <a:ln w="12700">
+            <a:solidFill>
+              <a:schemeClr val="tx1"/>
+            </a:solidFill>
+            <a:prstDash val="solid"/>
+          </a:ln>
+        </p:spPr>
+        <p:txBody>
+          <a:bodyPr/>
+          <a:lstStyle/>
+          <a:p>
+            <a:endParaRPr lang="en-IN"/>
+          </a:p>
+        </p:txBody>
+      </p:sp>
+      <p:sp>
+        <p:nvSpPr>
+          <p:cNvPr id="10" name="Key idea label"/>
+          <p:cNvSpPr txBox="1"/>
+          <p:nvPr/>
+        </p:nvSpPr>
+        <p:spPr>
+          <a:xfrm>
+            <a:off x="914400" y="4343400"/>
+            <a:ext cx="1645920" cy="1097280"/>
+          </a:xfrm>
+          <a:prstGeom prst="rect">
+            <a:avLst/>
+          </a:prstGeom>
+          <a:noFill/>
+          <a:ln/>
+        </p:spPr>
+        <p:txBody>
+          <a:bodyPr wrap="square" lIns="0" tIns="0" rIns="0" bIns="0" rtlCol="0" anchor="ctr"/>
+          <a:lstStyle/>
+          <a:p>
+            <a:pPr marL="0" indent="0">
+              <a:buNone/>
+            </a:pPr>
+            <a:r>
+              <a:rPr lang="en-US" sz="2000" b="1" dirty="0">
+                <a:solidFill>
+                  <a:schemeClr val="accent4"/>
+                </a:solidFill>
+              </a:rPr>
+              <a:t>Key idea</a:t>
+            </a:r>
+            <a:endParaRPr lang="en-US" sz="2000" dirty="0"/>
+          </a:p>
+        </p:txBody>
+      </p:sp>
+      <p:sp>
+        <p:nvSpPr>
+          <p:cNvPr id="11" name="Key idea text"/>
+          <p:cNvSpPr txBox="1"/>
+          <p:nvPr/>
+        </p:nvSpPr>
+        <p:spPr>
+          <a:xfrm>
+            <a:off x="2651760" y="4343400"/>
+            <a:ext cx="8625535" cy="1097280"/>
+          </a:xfrm>
+          <a:prstGeom prst="rect">
+            <a:avLst/>
+          </a:prstGeom>
+          <a:noFill/>
+          <a:ln/>
+        </p:spPr>
+        <p:txBody>
+          <a:bodyPr wrap="square" lIns="0" tIns="0" rIns="0" bIns="0" rtlCol="0" anchor="ctr"/>
+          <a:lstStyle/>
+          <a:p>
+            <a:pPr marL="0" indent="0">
+              <a:buNone/>
+            </a:pPr>
+            <a:r>
+              <a:rPr lang="en-US" sz="1600" dirty="0">
+                <a:solidFill>
+                  <a:schemeClr val="bg1"/>
+                </a:solidFill>
+              </a:rPr>
+              <a:t>Scale out, not up: our pipeline already runs as partitioned Spark jobs, so petabytes change where it runs, not what it computes.</a:t>
+            </a:r>
+            <a:endParaRPr lang="en-US" sz="1600" dirty="0"/>
+          </a:p>
+        </p:txBody>
+      </p:sp>
+      <p:sp>
+        <p:nvSpPr>
+          <p:cNvPr id="12" name="Source caption"/>
+          <p:cNvSpPr txBox="1"/>
+          <p:nvPr/>
+        </p:nvSpPr>
+        <p:spPr>
+          <a:xfrm>
+            <a:off x="548640" y="6263640"/>
+            <a:ext cx="10362895" cy="274320"/>
+          </a:xfrm>
+          <a:prstGeom prst="rect">
+            <a:avLst/>
+          </a:prstGeom>
+          <a:noFill/>
+          <a:ln/>
+        </p:spPr>
+        <p:txBody>
+          <a:bodyPr wrap="square" lIns="0" tIns="0" rIns="0" bIns="0" rtlCol="0" anchor="ctr"/>
+          <a:lstStyle/>
+          <a:p>
+            <a:pPr marL="0" indent="0">
+              <a:buNone/>
+            </a:pPr>
+            <a:r>
+              <a:rPr lang="en-US" sz="1100" dirty="0">
+                <a:solidFill>
+                  <a:schemeClr val="tx2"/>
+                </a:solidFill>
+              </a:rPr>
+              <a:t>Beyond this project's scope (PRD §15): everything here ran on one laptop, without a cluster or cloud storage.</a:t>
+            </a:r>
+            <a:endParaRPr lang="en-US" sz="1100" dirty="0"/>
+          </a:p>
+        </p:txBody>
+      </p:sp>
+      <p:sp>
+        <p:nvSpPr>
+          <p:cNvPr id="25" name="Slide Number Placeholder 0"/>
+          <p:cNvSpPr>
+            <a:spLocks noGrp="1"/>
+          </p:cNvSpPr>
+          <p:nvPr>
+            <p:ph type="sldNum" sz="quarter" idx="4294967295"/>
+          </p:nvPr>
+        </p:nvSpPr>
+        <p:spPr>
+          <a:xfrm>
+            <a:off x="11094415" y="6263640"/>
+            <a:ext cx="548640" cy="274320"/>
+          </a:xfrm>
+          <a:prstGeom prst="rect">
+            <a:avLst/>
+          </a:prstGeom>
+          <a:extLst>
+            <a:ext uri="{C572A759-6A51-4108-AA02-DFA0A04FC94B}">
+              <ma14:wrappingTextBoxFlag xmlns:ma14="http://schemas.microsoft.com/office/mac/drawingml/2011/main" xmlns="" val="0"/>
+            </a:ext>
+          </a:extLst>
+        </p:spPr>
+        <p:txBody>
+          <a:bodyPr/>
+          <a:lstStyle>
+            <a:lvl1pPr>
+              <a:defRPr sz="1100">
+                <a:solidFill>
+                  <a:schemeClr val="tx2"/>
+                </a:solidFill>
+              </a:defRPr>
+            </a:lvl1pPr>
+          </a:lstStyle>
+          <a:p>
+            <a:pPr algn="r"/>
+            <a:fld id="{F7021451-1387-4CA6-816F-3879F97B5CBC}" type="slidenum">
+              <a:rPr lang="en-US" b="0"/>
+              <a:t>6</a:t>
             </a:fld>
             <a:endParaRPr lang="en-US"/>
           </a:p>
@@ -4857,4 +5345,319 @@
     </a:ext>
   </a:extLst>
 </a:theme>
+</file>
+
+<file path=ppt/theme/theme2.xml><?xml version="1.0" encoding="utf-8"?>
+<a:theme xmlns:a="http://schemas.openxmlformats.org/drawingml/2006/main" name="Office Theme">
+  <a:themeElements>
+    <a:clrScheme name="Office">
+      <a:dk1>
+        <a:sysClr val="windowText" lastClr="000000"/>
+      </a:dk1>
+      <a:lt1>
+        <a:sysClr val="window" lastClr="FFFFFF"/>
+      </a:lt1>
+      <a:dk2>
+        <a:srgbClr val="0E2841"/>
+      </a:dk2>
+      <a:lt2>
+        <a:srgbClr val="E8E8E8"/>
+      </a:lt2>
+      <a:accent1>
+        <a:srgbClr val="156082"/>
+      </a:accent1>
+      <a:accent2>
+        <a:srgbClr val="E97132"/>
+      </a:accent2>
+      <a:accent3>
+        <a:srgbClr val="196B24"/>
+      </a:accent3>
+      <a:accent4>
+        <a:srgbClr val="0F9ED5"/>
+      </a:accent4>
+      <a:accent5>
+        <a:srgbClr val="A02B93"/>
+      </a:accent5>
+      <a:accent6>
+        <a:srgbClr val="4EA72E"/>
+      </a:accent6>
+      <a:hlink>
+        <a:srgbClr val="467886"/>
+      </a:hlink>
+      <a:folHlink>
+        <a:srgbClr val="96607D"/>
+      </a:folHlink>
+    </a:clrScheme>
+    <a:fontScheme name="Office">
+      <a:majorFont>
+        <a:latin typeface="Aptos Display" panose="02110004020202020204"/>
+        <a:ea typeface=""/>
+        <a:cs typeface=""/>
+        <a:font script="Jpan" typeface="游ゴシック Light"/>
+        <a:font script="Hang" typeface="맑은 고딕"/>
+        <a:font script="Hans" typeface="等线 Light"/>
+        <a:font script="Hant" typeface="新細明體"/>
+        <a:font script="Arab" typeface="Times New Roman"/>
+        <a:font script="Hebr" typeface="Times New Roman"/>
+        <a:font script="Thai" typeface="Angsana New"/>
+        <a:font script="Ethi" typeface="Nyala"/>
+        <a:font script="Beng" typeface="Vrinda"/>
+        <a:font script="Gujr" typeface="Shruti"/>
+        <a:font script="Khmr" typeface="MoolBoran"/>
+        <a:font script="Knda" typeface="Tunga"/>
+        <a:font script="Guru" typeface="Raavi"/>
+        <a:font script="Cans" typeface="Euphemia"/>
+        <a:font script="Cher" typeface="Plantagenet Cherokee"/>
+        <a:font script="Yiii" typeface="Microsoft Yi Baiti"/>
+        <a:font script="Tibt" typeface="Microsoft Himalaya"/>
+        <a:font script="Thaa" typeface="MV Boli"/>
+        <a:font script="Deva" typeface="Mangal"/>
+        <a:font script="Telu" typeface="Gautami"/>
+        <a:font script="Taml" typeface="Latha"/>
+        <a:font script="Syrc" typeface="Estrangelo Edessa"/>
+        <a:font script="Orya" typeface="Kalinga"/>
+        <a:font script="Mlym" typeface="Kartika"/>
+        <a:font script="Laoo" typeface="DokChampa"/>
+        <a:font script="Sinh" typeface="Iskoola Pota"/>
+        <a:font script="Mong" typeface="Mongolian Baiti"/>
+        <a:font script="Viet" typeface="Times New Roman"/>
+        <a:font script="Uigh" typeface="Microsoft Uighur"/>
+        <a:font script="Geor" typeface="Sylfaen"/>
+        <a:font script="Armn" typeface="Arial"/>
+        <a:font script="Bugi" typeface="Leelawadee UI"/>
+        <a:font script="Bopo" typeface="Microsoft JhengHei"/>
+        <a:font script="Java" typeface="Javanese Text"/>
+        <a:font script="Lisu" typeface="Segoe UI"/>
+        <a:font script="Mymr" typeface="Myanmar Text"/>
+        <a:font script="Nkoo" typeface="Ebrima"/>
+        <a:font script="Olck" typeface="Nirmala UI"/>
+        <a:font script="Osma" typeface="Ebrima"/>
+        <a:font script="Phag" typeface="Phagspa"/>
+        <a:font script="Syrn" typeface="Estrangelo Edessa"/>
+        <a:font script="Syrj" typeface="Estrangelo Edessa"/>
+        <a:font script="Syre" typeface="Estrangelo Edessa"/>
+        <a:font script="Sora" typeface="Nirmala UI"/>
+        <a:font script="Tale" typeface="Microsoft Tai Le"/>
+        <a:font script="Talu" typeface="Microsoft New Tai Lue"/>
+        <a:font script="Tfng" typeface="Ebrima"/>
+      </a:majorFont>
+      <a:minorFont>
+        <a:latin typeface="Aptos" panose="02110004020202020204"/>
+        <a:ea typeface=""/>
+        <a:cs typeface=""/>
+        <a:font script="Jpan" typeface="游ゴシック"/>
+        <a:font script="Hang" typeface="맑은 고딕"/>
+        <a:font script="Hans" typeface="等线"/>
+        <a:font script="Hant" typeface="新細明體"/>
+        <a:font script="Arab" typeface="Arial"/>
+        <a:font script="Hebr" typeface="Arial"/>
+        <a:font script="Thai" typeface="Cordia New"/>
+        <a:font script="Ethi" typeface="Nyala"/>
+        <a:font script="Beng" typeface="Vrinda"/>
+        <a:font script="Gujr" typeface="Shruti"/>
+        <a:font script="Khmr" typeface="DaunPenh"/>
+        <a:font script="Knda" typeface="Tunga"/>
+        <a:font script="Guru" typeface="Raavi"/>
+        <a:font script="Cans" typeface="Euphemia"/>
+        <a:font script="Cher" typeface="Plantagenet Cherokee"/>
+        <a:font script="Yiii" typeface="Microsoft Yi Baiti"/>
+        <a:font script="Tibt" typeface="Microsoft Himalaya"/>
+        <a:font script="Thaa" typeface="MV Boli"/>
+        <a:font script="Deva" typeface="Mangal"/>
+        <a:font script="Telu" typeface="Gautami"/>
+        <a:font script="Taml" typeface="Latha"/>
+        <a:font script="Syrc" typeface="Estrangelo Edessa"/>
+        <a:font script="Orya" typeface="Kalinga"/>
+        <a:font script="Mlym" typeface="Kartika"/>
+        <a:font script="Laoo" typeface="DokChampa"/>
+        <a:font script="Sinh" typeface="Iskoola Pota"/>
+        <a:font script="Mong" typeface="Mongolian Baiti"/>
+        <a:font script="Viet" typeface="Arial"/>
+        <a:font script="Uigh" typeface="Microsoft Uighur"/>
+        <a:font script="Geor" typeface="Sylfaen"/>
+        <a:font script="Armn" typeface="Arial"/>
+        <a:font script="Bugi" typeface="Leelawadee UI"/>
+        <a:font script="Bopo" typeface="Microsoft JhengHei"/>
+        <a:font script="Java" typeface="Javanese Text"/>
+        <a:font script="Lisu" typeface="Segoe UI"/>
+        <a:font script="Mymr" typeface="Myanmar Text"/>
+        <a:font script="Nkoo" typeface="Ebrima"/>
+        <a:font script="Olck" typeface="Nirmala UI"/>
+        <a:font script="Osma" typeface="Ebrima"/>
+        <a:font script="Phag" typeface="Phagspa"/>
+        <a:font script="Syrn" typeface="Estrangelo Edessa"/>
+        <a:font script="Syrj" typeface="Estrangelo Edessa"/>
+        <a:font script="Syre" typeface="Estrangelo Edessa"/>
+        <a:font script="Sora" typeface="Nirmala UI"/>
+        <a:font script="Tale" typeface="Microsoft Tai Le"/>
+        <a:font script="Talu" typeface="Microsoft New Tai Lue"/>
+        <a:font script="Tfng" typeface="Ebrima"/>
+      </a:minorFont>
+    </a:fontScheme>
+    <a:fmtScheme name="Office">
+      <a:fillStyleLst>
+        <a:solidFill>
+          <a:schemeClr val="phClr"/>
+        </a:solidFill>
+        <a:gradFill rotWithShape="1">
+          <a:gsLst>
+            <a:gs pos="0">
+              <a:schemeClr val="phClr">
+                <a:lumMod val="110000"/>
+                <a:satMod val="105000"/>
+                <a:tint val="67000"/>
+              </a:schemeClr>
+            </a:gs>
+            <a:gs pos="50000">
+              <a:schemeClr val="phClr">
+                <a:lumMod val="105000"/>
+                <a:satMod val="103000"/>
+                <a:tint val="73000"/>
+              </a:schemeClr>
+            </a:gs>
+            <a:gs pos="100000">
+              <a:schemeClr val="phClr">
+                <a:lumMod val="105000"/>
+                <a:satMod val="109000"/>
+                <a:tint val="81000"/>
+              </a:schemeClr>
+            </a:gs>
+          </a:gsLst>
+          <a:lin ang="5400000" scaled="0"/>
+        </a:gradFill>
+        <a:gradFill rotWithShape="1">
+          <a:gsLst>
+            <a:gs pos="0">
+              <a:schemeClr val="phClr">
+                <a:satMod val="103000"/>
+                <a:lumMod val="102000"/>
+                <a:tint val="94000"/>
+              </a:schemeClr>
+            </a:gs>
+            <a:gs pos="50000">
+              <a:schemeClr val="phClr">
+                <a:satMod val="110000"/>
+                <a:lumMod val="100000"/>
+                <a:shade val="100000"/>
+              </a:schemeClr>
+            </a:gs>
+            <a:gs pos="100000">
+              <a:schemeClr val="phClr">
+                <a:lumMod val="99000"/>
+                <a:satMod val="120000"/>
+                <a:shade val="78000"/>
+              </a:schemeClr>
+            </a:gs>
+          </a:gsLst>
+          <a:lin ang="5400000" scaled="0"/>
+        </a:gradFill>
+      </a:fillStyleLst>
+      <a:lnStyleLst>
+        <a:ln w="12700" cap="flat" cmpd="sng" algn="ctr">
+          <a:solidFill>
+            <a:schemeClr val="phClr"/>
+          </a:solidFill>
+          <a:prstDash val="solid"/>
+          <a:miter lim="800000"/>
+        </a:ln>
+        <a:ln w="19050" cap="flat" cmpd="sng" algn="ctr">
+          <a:solidFill>
+            <a:schemeClr val="phClr"/>
+          </a:solidFill>
+          <a:prstDash val="solid"/>
+          <a:miter lim="800000"/>
+        </a:ln>
+        <a:ln w="25400" cap="flat" cmpd="sng" algn="ctr">
+          <a:solidFill>
+            <a:schemeClr val="phClr"/>
+          </a:solidFill>
+          <a:prstDash val="solid"/>
+          <a:miter lim="800000"/>
+        </a:ln>
+      </a:lnStyleLst>
+      <a:effectStyleLst>
+        <a:effectStyle>
+          <a:effectLst/>
+        </a:effectStyle>
+        <a:effectStyle>
+          <a:effectLst/>
+        </a:effectStyle>
+        <a:effectStyle>
+          <a:effectLst>
+            <a:outerShdw blurRad="57150" dist="19050" dir="5400000" algn="ctr" rotWithShape="0">
+              <a:srgbClr val="000000">
+                <a:alpha val="63000"/>
+              </a:srgbClr>
+            </a:outerShdw>
+          </a:effectLst>
+        </a:effectStyle>
+      </a:effectStyleLst>
+      <a:bgFillStyleLst>
+        <a:solidFill>
+          <a:schemeClr val="phClr"/>
+        </a:solidFill>
+        <a:solidFill>
+          <a:schemeClr val="phClr">
+            <a:tint val="95000"/>
+            <a:satMod val="170000"/>
+          </a:schemeClr>
+        </a:solidFill>
+        <a:gradFill rotWithShape="1">
+          <a:gsLst>
+            <a:gs pos="0">
+              <a:schemeClr val="phClr">
+                <a:tint val="93000"/>
+                <a:satMod val="150000"/>
+                <a:shade val="98000"/>
+                <a:lumMod val="102000"/>
+              </a:schemeClr>
+            </a:gs>
+            <a:gs pos="50000">
+              <a:schemeClr val="phClr">
+                <a:tint val="98000"/>
+                <a:satMod val="130000"/>
+                <a:shade val="90000"/>
+                <a:lumMod val="103000"/>
+              </a:schemeClr>
+            </a:gs>
+            <a:gs pos="100000">
+              <a:schemeClr val="phClr">
+                <a:shade val="63000"/>
+                <a:satMod val="120000"/>
+              </a:schemeClr>
+            </a:gs>
+          </a:gsLst>
+          <a:lin ang="5400000" scaled="0"/>
+        </a:gradFill>
+      </a:bgFillStyleLst>
+    </a:fmtScheme>
+  </a:themeElements>
+  <a:objectDefaults>
+    <a:lnDef>
+      <a:spPr/>
+      <a:bodyPr/>
+      <a:lstStyle/>
+      <a:style>
+        <a:lnRef idx="2">
+          <a:schemeClr val="accent1"/>
+        </a:lnRef>
+        <a:fillRef idx="0">
+          <a:schemeClr val="accent1"/>
+        </a:fillRef>
+        <a:effectRef idx="1">
+          <a:schemeClr val="accent1"/>
+        </a:effectRef>
+        <a:fontRef idx="minor">
+          <a:schemeClr val="tx1"/>
+        </a:fontRef>
+      </a:style>
+    </a:lnDef>
+  </a:objectDefaults>
+  <a:extraClrSchemeLst/>
+  <a:extLst>
+    <a:ext uri="{05A4C25C-085E-4340-85A3-A5531E510DB2}">
+      <thm15:themeFamily xmlns:thm15="http://schemas.microsoft.com/office/thememl/2012/main" name="Office Theme" id="{2E142A2C-CD16-42D6-873A-C26D2A0506FA}" vid="{1BDDFF52-6CD6-40A5-AB3C-68EB2F1E4D0A}"/>
+    </a:ext>
+  </a:extLst>
+</a:theme>
 </file>
</xml_diff>